<commit_message>
Update training repository to latest state
</commit_message>
<xml_diff>
--- a/slides/DGE-METRIC_Online_Day1_Slides.pptx
+++ b/slides/DGE-METRIC_Online_Day1_Slides.pptx
@@ -15,10 +15,9 @@
     <p:sldId id="263" r:id="rId9"/>
     <p:sldId id="264" r:id="rId10"/>
     <p:sldId id="265" r:id="rId11"/>
-    <p:sldId id="269" r:id="rId12"/>
-    <p:sldId id="266" r:id="rId13"/>
-    <p:sldId id="267" r:id="rId14"/>
-    <p:sldId id="268" r:id="rId15"/>
+    <p:sldId id="266" r:id="rId12"/>
+    <p:sldId id="267" r:id="rId13"/>
+    <p:sldId id="268" r:id="rId14"/>
   </p:sldIdLst>
   <p:sldSz cx="12192000" cy="6858000"/>
   <p:notesSz cx="6858000" cy="9144000"/>
@@ -315,7 +314,7 @@
           <a:p>
             <a:fld id="{5BCAD085-E8A6-8845-BD4E-CB4CCA059FC4}" type="datetimeFigureOut">
               <a:rPr lang="en-US" smtClean="0"/>
-              <a:t>7/15/2026</a:t>
+              <a:t>7/19/2026</a:t>
             </a:fld>
             <a:endParaRPr lang="en-US"/>
           </a:p>
@@ -483,7 +482,7 @@
           <a:p>
             <a:fld id="{5BCAD085-E8A6-8845-BD4E-CB4CCA059FC4}" type="datetimeFigureOut">
               <a:rPr lang="en-US" smtClean="0"/>
-              <a:t>7/15/2026</a:t>
+              <a:t>7/19/2026</a:t>
             </a:fld>
             <a:endParaRPr lang="en-US"/>
           </a:p>
@@ -661,7 +660,7 @@
           <a:p>
             <a:fld id="{5BCAD085-E8A6-8845-BD4E-CB4CCA059FC4}" type="datetimeFigureOut">
               <a:rPr lang="en-US" smtClean="0"/>
-              <a:t>7/15/2026</a:t>
+              <a:t>7/19/2026</a:t>
             </a:fld>
             <a:endParaRPr lang="en-US"/>
           </a:p>
@@ -829,7 +828,7 @@
           <a:p>
             <a:fld id="{5BCAD085-E8A6-8845-BD4E-CB4CCA059FC4}" type="datetimeFigureOut">
               <a:rPr lang="en-US" smtClean="0"/>
-              <a:t>7/15/2026</a:t>
+              <a:t>7/19/2026</a:t>
             </a:fld>
             <a:endParaRPr lang="en-US"/>
           </a:p>
@@ -1074,7 +1073,7 @@
           <a:p>
             <a:fld id="{5BCAD085-E8A6-8845-BD4E-CB4CCA059FC4}" type="datetimeFigureOut">
               <a:rPr lang="en-US" smtClean="0"/>
-              <a:t>7/15/2026</a:t>
+              <a:t>7/19/2026</a:t>
             </a:fld>
             <a:endParaRPr lang="en-US"/>
           </a:p>
@@ -1359,7 +1358,7 @@
           <a:p>
             <a:fld id="{5BCAD085-E8A6-8845-BD4E-CB4CCA059FC4}" type="datetimeFigureOut">
               <a:rPr lang="en-US" smtClean="0"/>
-              <a:t>7/15/2026</a:t>
+              <a:t>7/19/2026</a:t>
             </a:fld>
             <a:endParaRPr lang="en-US"/>
           </a:p>
@@ -1778,7 +1777,7 @@
           <a:p>
             <a:fld id="{5BCAD085-E8A6-8845-BD4E-CB4CCA059FC4}" type="datetimeFigureOut">
               <a:rPr lang="en-US" smtClean="0"/>
-              <a:t>7/15/2026</a:t>
+              <a:t>7/19/2026</a:t>
             </a:fld>
             <a:endParaRPr lang="en-US"/>
           </a:p>
@@ -1895,7 +1894,7 @@
           <a:p>
             <a:fld id="{5BCAD085-E8A6-8845-BD4E-CB4CCA059FC4}" type="datetimeFigureOut">
               <a:rPr lang="en-US" smtClean="0"/>
-              <a:t>7/15/2026</a:t>
+              <a:t>7/19/2026</a:t>
             </a:fld>
             <a:endParaRPr lang="en-US"/>
           </a:p>
@@ -1990,7 +1989,7 @@
           <a:p>
             <a:fld id="{5BCAD085-E8A6-8845-BD4E-CB4CCA059FC4}" type="datetimeFigureOut">
               <a:rPr lang="en-US" smtClean="0"/>
-              <a:t>7/15/2026</a:t>
+              <a:t>7/19/2026</a:t>
             </a:fld>
             <a:endParaRPr lang="en-US"/>
           </a:p>
@@ -2265,7 +2264,7 @@
           <a:p>
             <a:fld id="{5BCAD085-E8A6-8845-BD4E-CB4CCA059FC4}" type="datetimeFigureOut">
               <a:rPr lang="en-US" smtClean="0"/>
-              <a:t>7/15/2026</a:t>
+              <a:t>7/19/2026</a:t>
             </a:fld>
             <a:endParaRPr lang="en-US"/>
           </a:p>
@@ -2517,7 +2516,7 @@
           <a:p>
             <a:fld id="{5BCAD085-E8A6-8845-BD4E-CB4CCA059FC4}" type="datetimeFigureOut">
               <a:rPr lang="en-US" smtClean="0"/>
-              <a:t>7/15/2026</a:t>
+              <a:t>7/19/2026</a:t>
             </a:fld>
             <a:endParaRPr lang="en-US"/>
           </a:p>
@@ -2728,7 +2727,7 @@
           <a:p>
             <a:fld id="{5BCAD085-E8A6-8845-BD4E-CB4CCA059FC4}" type="datetimeFigureOut">
               <a:rPr lang="en-US" smtClean="0"/>
-              <a:t>7/15/2026</a:t>
+              <a:t>7/19/2026</a:t>
             </a:fld>
             <a:endParaRPr lang="en-US"/>
           </a:p>
@@ -3588,7 +3587,7 @@
                 </a:solidFill>
                 <a:latin typeface="Calibri"/>
               </a:rPr>
-              <a:t>The Energy-Efficiency Scenario, in Full Detail</a:t>
+              <a:t>The EE And RTS Families, in Full Detail</a:t>
             </a:r>
           </a:p>
         </p:txBody>
@@ -3759,13 +3758,13 @@
               </a:spcAft>
             </a:pPr>
             <a:r>
-              <a:rPr sz="1700" b="0" i="0">
+              <a:rPr sz="1700" b="0" i="0" dirty="0">
                 <a:solidFill>
                   <a:srgbClr val="232323"/>
                 </a:solidFill>
                 <a:latin typeface="Calibri"/>
               </a:rPr>
-              <a:t>•  Narrative: efficiency gains in industry and services (EE_PDP8 / EE_Directive10), plus rooftop solar (RTS) capacity and battery storage (BESS) integration</a:t>
+              <a:t>•  Three named EE or RTS families are in scope: EE_PDP8, EE_Directive10, and EE_PDP8_PV_BESS</a:t>
             </a:r>
           </a:p>
           <a:p>
@@ -3775,13 +3774,49 @@
               </a:spcAft>
             </a:pPr>
             <a:r>
-              <a:rPr sz="1700" b="0" i="0">
+              <a:rPr sz="1700" b="0" i="0" dirty="0">
                 <a:solidFill>
                   <a:srgbClr val="232323"/>
                 </a:solidFill>
                 <a:latin typeface="Calibri"/>
               </a:rPr>
-              <a:t>•  Core channels: energy-productivity shock (exo_AI) lowers energy intensity in industry &amp; services; adaptation-capital cost channel (exo_GA) captures upfront EE/RTS/BESS investment; household RTS displaces purchased grid electricity directly</a:t>
+              <a:t>•  Core channels: </a:t>
+            </a:r>
+            <a:r>
+              <a:rPr sz="1700" b="0" i="0" dirty="0" err="1">
+                <a:solidFill>
+                  <a:srgbClr val="232323"/>
+                </a:solidFill>
+                <a:latin typeface="Calibri"/>
+              </a:rPr>
+              <a:t>exo_AI</a:t>
+            </a:r>
+            <a:r>
+              <a:rPr sz="1700" b="0" i="0" dirty="0">
+                <a:solidFill>
+                  <a:srgbClr val="232323"/>
+                </a:solidFill>
+                <a:latin typeface="Calibri"/>
+              </a:rPr>
+              <a:t> lowers energy intensity in industry and services; </a:t>
+            </a:r>
+            <a:r>
+              <a:rPr sz="1700" b="0" i="0" dirty="0" err="1">
+                <a:solidFill>
+                  <a:srgbClr val="232323"/>
+                </a:solidFill>
+                <a:latin typeface="Calibri"/>
+              </a:rPr>
+              <a:t>exo_PVEff</a:t>
+            </a:r>
+            <a:r>
+              <a:rPr sz="1700" b="0" i="0" dirty="0">
+                <a:solidFill>
+                  <a:srgbClr val="232323"/>
+                </a:solidFill>
+                <a:latin typeface="Calibri"/>
+              </a:rPr>
+              <a:t> and GA_3 capture rooftop PV and BESS-related channels where applicable</a:t>
             </a:r>
           </a:p>
           <a:p>
@@ -3791,13 +3826,13 @@
               </a:spcAft>
             </a:pPr>
             <a:r>
-              <a:rPr sz="1700" b="0" i="0">
+              <a:rPr sz="1700" b="0" i="0" dirty="0">
                 <a:solidFill>
                   <a:srgbClr val="232323"/>
                 </a:solidFill>
                 <a:latin typeface="Calibri"/>
               </a:rPr>
-              <a:t>•  2030 savings potential: ≈7.4% industry, ≈5.1% services, ≈11.6% households (rooftop PV, via the capital channel)</a:t>
+              <a:t>•  2030 savings potential: ≈7.4% manufacturing, ≈5.1% services/commercial, ≈11.6% households</a:t>
             </a:r>
           </a:p>
           <a:p>
@@ -3807,13 +3842,13 @@
               </a:spcAft>
             </a:pPr>
             <a:r>
-              <a:rPr sz="1700" b="0" i="0">
+              <a:rPr sz="1700" b="0" i="0" dirty="0">
                 <a:solidFill>
                   <a:srgbClr val="232323"/>
                 </a:solidFill>
                 <a:latin typeface="Calibri"/>
               </a:rPr>
-              <a:t>•  Quantified investment need: ≈USD 361 million/year (≈0.076% of GDP)</a:t>
+              <a:t>•  Quantified investment need: ≈USD 361 million/year (≈0.076% of 2024 GDP)</a:t>
             </a:r>
           </a:p>
           <a:p>
@@ -3823,7 +3858,7 @@
               </a:spcAft>
             </a:pPr>
             <a:r>
-              <a:rPr sz="1700" b="1" i="0">
+              <a:rPr sz="1700" b="1" i="0" dirty="0">
                 <a:solidFill>
                   <a:srgbClr val="232323"/>
                 </a:solidFill>
@@ -3839,13 +3874,31 @@
               </a:spcAft>
             </a:pPr>
             <a:r>
-              <a:rPr sz="1700" b="0" i="0">
+              <a:rPr sz="1700" b="0" i="0" dirty="0">
                 <a:solidFill>
                   <a:srgbClr val="232323"/>
                 </a:solidFill>
                 <a:latin typeface="Calibri"/>
               </a:rPr>
-              <a:t>•  Compared against the Baseline (PDP8 plan, no carbon cap) and against each other — Full vs NoBESS (e.g. EE_Directive10 vs EE_Directive10_NoBESS) isolates the BESS contribution</a:t>
+              <a:t>•  Group 1's EE_PDP8 Full and </a:t>
+            </a:r>
+            <a:r>
+              <a:rPr sz="1700" b="0" i="0" dirty="0" err="1">
+                <a:solidFill>
+                  <a:srgbClr val="232323"/>
+                </a:solidFill>
+                <a:latin typeface="Calibri"/>
+              </a:rPr>
+              <a:t>NoBESS</a:t>
+            </a:r>
+            <a:r>
+              <a:rPr sz="1700" b="0" i="0" dirty="0">
+                <a:solidFill>
+                  <a:srgbClr val="232323"/>
+                </a:solidFill>
+                <a:latin typeface="Calibri"/>
+              </a:rPr>
+              <a:t> variants are numerically identical because the BESS channel is zero throughout</a:t>
             </a:r>
           </a:p>
         </p:txBody>
@@ -3999,7 +4052,7 @@
                 </a:solidFill>
                 <a:latin typeface="Calibri"/>
               </a:rPr>
-              <a:t>BLOCK 6 · 35 MIN</a:t>
+              <a:t>BLOCK 7 · 30 MIN</a:t>
             </a:r>
           </a:p>
           <a:p>
@@ -4010,7 +4063,7 @@
                 </a:solidFill>
                 <a:latin typeface="Calibri"/>
               </a:rPr>
-              <a:t>The Six-Scenario EE Matrix</a:t>
+              <a:t>Draft Your Energy-Efficiency Scenario Metadata Sheet</a:t>
             </a:r>
           </a:p>
         </p:txBody>
@@ -4153,1096 +4206,104 @@
           </a:p>
         </p:txBody>
       </p:sp>
-      <p:graphicFrame>
-        <p:nvGraphicFramePr>
-          <p:cNvPr id="9" name="Table 8"/>
-          <p:cNvGraphicFramePr>
-            <a:graphicFrameLocks noGrp="1"/>
-          </p:cNvGraphicFramePr>
+      <p:sp>
+        <p:nvSpPr>
+          <p:cNvPr id="9" name="TextBox 8"/>
+          <p:cNvSpPr txBox="1"/>
           <p:nvPr/>
-        </p:nvGraphicFramePr>
-        <p:xfrm>
-          <a:off x="502920" y="1554480"/>
-          <a:ext cx="11185855" cy="4389120"/>
-        </p:xfrm>
-        <a:graphic>
-          <a:graphicData uri="http://schemas.openxmlformats.org/drawingml/2006/table">
-            <a:tbl>
-              <a:tblPr firstRow="1" bandRow="1">
-                <a:tableStyleId>{5C22544A-7EE6-4342-B048-85BDC9FD1C3A}</a:tableStyleId>
-              </a:tblPr>
-              <a:tblGrid>
-                <a:gridCol w="1143000">
-                  <a:extLst>
-                    <a:ext uri="{9D8B030D-6E8A-4147-A177-3AD203B41FA5}">
-                      <a16:colId xmlns:a16="http://schemas.microsoft.com/office/drawing/2014/main" val="20000"/>
-                    </a:ext>
-                  </a:extLst>
-                </a:gridCol>
-                <a:gridCol w="2011680">
-                  <a:extLst>
-                    <a:ext uri="{9D8B030D-6E8A-4147-A177-3AD203B41FA5}">
-                      <a16:colId xmlns:a16="http://schemas.microsoft.com/office/drawing/2014/main" val="1726060542"/>
-                    </a:ext>
-                  </a:extLst>
-                </a:gridCol>
-                <a:gridCol w="1417320">
-                  <a:extLst>
-                    <a:ext uri="{9D8B030D-6E8A-4147-A177-3AD203B41FA5}">
-                      <a16:colId xmlns:a16="http://schemas.microsoft.com/office/drawing/2014/main" val="20001"/>
-                    </a:ext>
-                  </a:extLst>
-                </a:gridCol>
-                <a:gridCol w="2011680">
-                  <a:extLst>
-                    <a:ext uri="{9D8B030D-6E8A-4147-A177-3AD203B41FA5}">
-                      <a16:colId xmlns:a16="http://schemas.microsoft.com/office/drawing/2014/main" val="20002"/>
-                    </a:ext>
-                  </a:extLst>
-                </a:gridCol>
-                <a:gridCol w="2011680">
-                  <a:extLst>
-                    <a:ext uri="{9D8B030D-6E8A-4147-A177-3AD203B41FA5}">
-                      <a16:colId xmlns:a16="http://schemas.microsoft.com/office/drawing/2014/main" val="20003"/>
-                    </a:ext>
-                  </a:extLst>
-                </a:gridCol>
-                <a:gridCol w="2590495">
-                  <a:extLst>
-                    <a:ext uri="{9D8B030D-6E8A-4147-A177-3AD203B41FA5}">
-                      <a16:colId xmlns:a16="http://schemas.microsoft.com/office/drawing/2014/main" val="1573726024"/>
-                    </a:ext>
-                  </a:extLst>
-                </a:gridCol>
-              </a:tblGrid>
-              <a:tr h="627017">
-                <a:tc>
-                  <a:txBody>
-                    <a:bodyPr/>
-                    <a:lstStyle/>
-                    <a:p>
-                      <a:r>
-                        <a:rPr sz="1300" b="1" i="0">
-                          <a:solidFill>
-                            <a:srgbClr val="FFFFFF"/>
-                          </a:solidFill>
-                          <a:latin typeface="Calibri"/>
-                        </a:rPr>
-                        <a:t>Group</a:t>
-                      </a:r>
-                    </a:p>
-                  </a:txBody>
-                  <a:tcPr marT="50800" marB="50800" anchor="ctr">
-                    <a:solidFill>
-                      <a:srgbClr val="CC071E"/>
-                    </a:solidFill>
-                  </a:tcPr>
-                </a:tc>
-                <a:tc>
-                  <a:txBody>
-                    <a:bodyPr/>
-                    <a:lstStyle/>
-                    <a:p>
-                      <a:r>
-                        <a:rPr sz="1300" b="1" i="0">
-                          <a:solidFill>
-                            <a:srgbClr val="FFFFFF"/>
-                          </a:solidFill>
-                          <a:latin typeface="Calibri"/>
-                        </a:rPr>
-                        <a:t>Scenario ID</a:t>
-                      </a:r>
-                    </a:p>
-                  </a:txBody>
-                  <a:tcPr marT="50800" marB="50800" anchor="ctr">
-                    <a:solidFill>
-                      <a:srgbClr val="CC071E"/>
-                    </a:solidFill>
-                  </a:tcPr>
-                </a:tc>
-                <a:tc>
-                  <a:txBody>
-                    <a:bodyPr/>
-                    <a:lstStyle/>
-                    <a:p>
-                      <a:r>
-                        <a:rPr sz="1300" b="1" i="0">
-                          <a:solidFill>
-                            <a:srgbClr val="FFFFFF"/>
-                          </a:solidFill>
-                          <a:latin typeface="Calibri"/>
-                        </a:rPr>
-                        <a:t>BESS variant</a:t>
-                      </a:r>
-                    </a:p>
-                  </a:txBody>
-                  <a:tcPr marT="50800" marB="50800" anchor="ctr">
-                    <a:solidFill>
-                      <a:srgbClr val="CC071E"/>
-                    </a:solidFill>
-                  </a:tcPr>
-                </a:tc>
-                <a:tc>
-                  <a:txBody>
-                    <a:bodyPr/>
-                    <a:lstStyle/>
-                    <a:p>
-                      <a:r>
-                        <a:rPr sz="1300" b="1" i="0" dirty="0">
-                          <a:solidFill>
-                            <a:srgbClr val="FFFFFF"/>
-                          </a:solidFill>
-                          <a:latin typeface="Calibri"/>
-                        </a:rPr>
-                        <a:t>EE / RTS package</a:t>
-                      </a:r>
-                    </a:p>
-                  </a:txBody>
-                  <a:tcPr marT="50800" marB="50800" anchor="ctr">
-                    <a:solidFill>
-                      <a:srgbClr val="CC071E"/>
-                    </a:solidFill>
-                  </a:tcPr>
-                </a:tc>
-                <a:tc>
-                  <a:txBody>
-                    <a:bodyPr/>
-                    <a:lstStyle/>
-                    <a:p>
-                      <a:r>
-                        <a:rPr sz="1300" b="1" i="0">
-                          <a:solidFill>
-                            <a:srgbClr val="FFFFFF"/>
-                          </a:solidFill>
-                          <a:latin typeface="Calibri"/>
-                        </a:rPr>
-                        <a:t>exo_AI ind / serv (2030)</a:t>
-                      </a:r>
-                    </a:p>
-                  </a:txBody>
-                  <a:tcPr marT="50800" marB="50800" anchor="ctr">
-                    <a:solidFill>
-                      <a:srgbClr val="CC071E"/>
-                    </a:solidFill>
-                  </a:tcPr>
-                </a:tc>
-                <a:tc>
-                  <a:txBody>
-                    <a:bodyPr/>
-                    <a:lstStyle/>
-                    <a:p>
-                      <a:r>
-                        <a:rPr sz="1300" b="1" i="0">
-                          <a:solidFill>
-                            <a:srgbClr val="FFFFFF"/>
-                          </a:solidFill>
-                          <a:latin typeface="Calibri"/>
-                        </a:rPr>
-                        <a:t>exo_PVEff / GA_3 (2030)</a:t>
-                      </a:r>
-                    </a:p>
-                  </a:txBody>
-                  <a:tcPr marT="50800" marB="50800" anchor="ctr">
-                    <a:solidFill>
-                      <a:srgbClr val="CC071E"/>
-                    </a:solidFill>
-                  </a:tcPr>
-                </a:tc>
-                <a:extLst>
-                  <a:ext uri="{0D108BD9-81ED-4DB2-BD59-A6C34878D82A}">
-                    <a16:rowId xmlns:a16="http://schemas.microsoft.com/office/drawing/2014/main" val="10000"/>
-                  </a:ext>
-                </a:extLst>
-              </a:tr>
-              <a:tr h="627017">
-                <a:tc>
-                  <a:txBody>
-                    <a:bodyPr/>
-                    <a:lstStyle/>
-                    <a:p>
-                      <a:r>
-                        <a:rPr sz="1300" b="1" i="0">
-                          <a:solidFill>
-                            <a:srgbClr val="232323"/>
-                          </a:solidFill>
-                          <a:latin typeface="Calibri"/>
-                        </a:rPr>
-                        <a:t>Group 1</a:t>
-                      </a:r>
-                    </a:p>
-                  </a:txBody>
-                  <a:tcPr marT="38100" marB="38100" anchor="ctr">
-                    <a:solidFill>
-                      <a:srgbClr val="FFFFFF"/>
-                    </a:solidFill>
-                  </a:tcPr>
-                </a:tc>
-                <a:tc>
-                  <a:txBody>
-                    <a:bodyPr/>
-                    <a:lstStyle/>
-                    <a:p>
-                      <a:r>
-                        <a:rPr sz="1300" b="1" i="0">
-                          <a:solidFill>
-                            <a:srgbClr val="232323"/>
-                          </a:solidFill>
-                          <a:latin typeface="Calibri"/>
-                        </a:rPr>
-                        <a:t>EE_PDP8</a:t>
-                      </a:r>
-                    </a:p>
-                  </a:txBody>
-                  <a:tcPr marT="38100" marB="38100" anchor="ctr">
-                    <a:solidFill>
-                      <a:srgbClr val="FFFFFF"/>
-                    </a:solidFill>
-                  </a:tcPr>
-                </a:tc>
-                <a:tc>
-                  <a:txBody>
-                    <a:bodyPr/>
-                    <a:lstStyle/>
-                    <a:p>
-                      <a:r>
-                        <a:rPr sz="1300" b="0" i="0">
-                          <a:solidFill>
-                            <a:srgbClr val="232323"/>
-                          </a:solidFill>
-                          <a:latin typeface="Calibri"/>
-                        </a:rPr>
-                        <a:t>Full</a:t>
-                      </a:r>
-                    </a:p>
-                  </a:txBody>
-                  <a:tcPr marT="38100" marB="38100" anchor="ctr">
-                    <a:solidFill>
-                      <a:srgbClr val="FFFFFF"/>
-                    </a:solidFill>
-                  </a:tcPr>
-                </a:tc>
-                <a:tc>
-                  <a:txBody>
-                    <a:bodyPr/>
-                    <a:lstStyle/>
-                    <a:p>
-                      <a:r>
-                        <a:rPr sz="1300" b="0" i="0">
-                          <a:solidFill>
-                            <a:srgbClr val="232323"/>
-                          </a:solidFill>
-                          <a:latin typeface="Calibri"/>
-                        </a:rPr>
-                        <a:t>PDP8 reference (moderate EE)</a:t>
-                      </a:r>
-                    </a:p>
-                  </a:txBody>
-                  <a:tcPr marT="38100" marB="38100" anchor="ctr">
-                    <a:solidFill>
-                      <a:srgbClr val="FFFFFF"/>
-                    </a:solidFill>
-                  </a:tcPr>
-                </a:tc>
-                <a:tc>
-                  <a:txBody>
-                    <a:bodyPr/>
-                    <a:lstStyle/>
-                    <a:p>
-                      <a:r>
-                        <a:rPr sz="1300" b="0" i="0" dirty="0">
-                          <a:solidFill>
-                            <a:srgbClr val="232323"/>
-                          </a:solidFill>
-                          <a:latin typeface="Calibri"/>
-                        </a:rPr>
-                        <a:t>0.143 / 0.195</a:t>
-                      </a:r>
-                    </a:p>
-                  </a:txBody>
-                  <a:tcPr marT="38100" marB="38100" anchor="ctr">
-                    <a:solidFill>
-                      <a:srgbClr val="FFFFFF"/>
-                    </a:solidFill>
-                  </a:tcPr>
-                </a:tc>
-                <a:tc>
-                  <a:txBody>
-                    <a:bodyPr/>
-                    <a:lstStyle/>
-                    <a:p>
-                      <a:r>
-                        <a:rPr sz="1300" b="0" i="0" dirty="0">
-                          <a:solidFill>
-                            <a:srgbClr val="232323"/>
-                          </a:solidFill>
-                          <a:latin typeface="Calibri"/>
-                        </a:rPr>
-                        <a:t>0.000 / 0.000</a:t>
-                      </a:r>
-                    </a:p>
-                  </a:txBody>
-                  <a:tcPr marT="38100" marB="38100" anchor="ctr">
-                    <a:solidFill>
-                      <a:srgbClr val="FFFFFF"/>
-                    </a:solidFill>
-                  </a:tcPr>
-                </a:tc>
-                <a:extLst>
-                  <a:ext uri="{0D108BD9-81ED-4DB2-BD59-A6C34878D82A}">
-                    <a16:rowId xmlns:a16="http://schemas.microsoft.com/office/drawing/2014/main" val="10001"/>
-                  </a:ext>
-                </a:extLst>
-              </a:tr>
-              <a:tr h="627017">
-                <a:tc>
-                  <a:txBody>
-                    <a:bodyPr/>
-                    <a:lstStyle/>
-                    <a:p>
-                      <a:r>
-                        <a:rPr sz="1300" b="1" i="0">
-                          <a:solidFill>
-                            <a:srgbClr val="232323"/>
-                          </a:solidFill>
-                          <a:latin typeface="Calibri"/>
-                        </a:rPr>
-                        <a:t>Group 1</a:t>
-                      </a:r>
-                    </a:p>
-                  </a:txBody>
-                  <a:tcPr marT="38100" marB="38100" anchor="ctr">
-                    <a:solidFill>
-                      <a:srgbClr val="F5F5F5"/>
-                    </a:solidFill>
-                  </a:tcPr>
-                </a:tc>
-                <a:tc>
-                  <a:txBody>
-                    <a:bodyPr/>
-                    <a:lstStyle/>
-                    <a:p>
-                      <a:r>
-                        <a:rPr sz="1300" b="1" i="0">
-                          <a:solidFill>
-                            <a:srgbClr val="232323"/>
-                          </a:solidFill>
-                          <a:latin typeface="Calibri"/>
-                        </a:rPr>
-                        <a:t>EE_PDP8_NoBESS</a:t>
-                      </a:r>
-                    </a:p>
-                  </a:txBody>
-                  <a:tcPr marT="38100" marB="38100" anchor="ctr">
-                    <a:solidFill>
-                      <a:srgbClr val="F5F5F5"/>
-                    </a:solidFill>
-                  </a:tcPr>
-                </a:tc>
-                <a:tc>
-                  <a:txBody>
-                    <a:bodyPr/>
-                    <a:lstStyle/>
-                    <a:p>
-                      <a:r>
-                        <a:rPr sz="1300" b="0" i="0">
-                          <a:solidFill>
-                            <a:srgbClr val="232323"/>
-                          </a:solidFill>
-                          <a:latin typeface="Calibri"/>
-                        </a:rPr>
-                        <a:t>NoBESS</a:t>
-                      </a:r>
-                    </a:p>
-                  </a:txBody>
-                  <a:tcPr marT="38100" marB="38100" anchor="ctr">
-                    <a:solidFill>
-                      <a:srgbClr val="F5F5F5"/>
-                    </a:solidFill>
-                  </a:tcPr>
-                </a:tc>
-                <a:tc>
-                  <a:txBody>
-                    <a:bodyPr/>
-                    <a:lstStyle/>
-                    <a:p>
-                      <a:r>
-                        <a:rPr sz="1300" b="0" i="0">
-                          <a:solidFill>
-                            <a:srgbClr val="232323"/>
-                          </a:solidFill>
-                          <a:latin typeface="Calibri"/>
-                        </a:rPr>
-                        <a:t>PDP8 reference (moderate EE)</a:t>
-                      </a:r>
-                    </a:p>
-                  </a:txBody>
-                  <a:tcPr marT="38100" marB="38100" anchor="ctr">
-                    <a:solidFill>
-                      <a:srgbClr val="F5F5F5"/>
-                    </a:solidFill>
-                  </a:tcPr>
-                </a:tc>
-                <a:tc>
-                  <a:txBody>
-                    <a:bodyPr/>
-                    <a:lstStyle/>
-                    <a:p>
-                      <a:r>
-                        <a:rPr sz="1300" b="0" i="0">
-                          <a:solidFill>
-                            <a:srgbClr val="232323"/>
-                          </a:solidFill>
-                          <a:latin typeface="Calibri"/>
-                        </a:rPr>
-                        <a:t>0.143 / 0.195</a:t>
-                      </a:r>
-                    </a:p>
-                  </a:txBody>
-                  <a:tcPr marT="38100" marB="38100" anchor="ctr">
-                    <a:solidFill>
-                      <a:srgbClr val="F5F5F5"/>
-                    </a:solidFill>
-                  </a:tcPr>
-                </a:tc>
-                <a:tc>
-                  <a:txBody>
-                    <a:bodyPr/>
-                    <a:lstStyle/>
-                    <a:p>
-                      <a:r>
-                        <a:rPr sz="1300" b="0" i="0">
-                          <a:solidFill>
-                            <a:srgbClr val="232323"/>
-                          </a:solidFill>
-                          <a:latin typeface="Calibri"/>
-                        </a:rPr>
-                        <a:t>0.000 / 0.000</a:t>
-                      </a:r>
-                    </a:p>
-                  </a:txBody>
-                  <a:tcPr marT="38100" marB="38100" anchor="ctr">
-                    <a:solidFill>
-                      <a:srgbClr val="F5F5F5"/>
-                    </a:solidFill>
-                  </a:tcPr>
-                </a:tc>
-                <a:extLst>
-                  <a:ext uri="{0D108BD9-81ED-4DB2-BD59-A6C34878D82A}">
-                    <a16:rowId xmlns:a16="http://schemas.microsoft.com/office/drawing/2014/main" val="10002"/>
-                  </a:ext>
-                </a:extLst>
-              </a:tr>
-              <a:tr h="627017">
-                <a:tc>
-                  <a:txBody>
-                    <a:bodyPr/>
-                    <a:lstStyle/>
-                    <a:p>
-                      <a:r>
-                        <a:rPr sz="1300" b="1" i="0">
-                          <a:solidFill>
-                            <a:srgbClr val="232323"/>
-                          </a:solidFill>
-                          <a:latin typeface="Calibri"/>
-                        </a:rPr>
-                        <a:t>Group 2</a:t>
-                      </a:r>
-                    </a:p>
-                  </a:txBody>
-                  <a:tcPr marT="38100" marB="38100" anchor="ctr">
-                    <a:solidFill>
-                      <a:srgbClr val="FFFFFF"/>
-                    </a:solidFill>
-                  </a:tcPr>
-                </a:tc>
-                <a:tc>
-                  <a:txBody>
-                    <a:bodyPr/>
-                    <a:lstStyle/>
-                    <a:p>
-                      <a:r>
-                        <a:rPr sz="1300" b="1" i="0">
-                          <a:solidFill>
-                            <a:srgbClr val="232323"/>
-                          </a:solidFill>
-                          <a:latin typeface="Calibri"/>
-                        </a:rPr>
-                        <a:t>EE_Directive10</a:t>
-                      </a:r>
-                    </a:p>
-                  </a:txBody>
-                  <a:tcPr marT="38100" marB="38100" anchor="ctr">
-                    <a:solidFill>
-                      <a:srgbClr val="FFFFFF"/>
-                    </a:solidFill>
-                  </a:tcPr>
-                </a:tc>
-                <a:tc>
-                  <a:txBody>
-                    <a:bodyPr/>
-                    <a:lstStyle/>
-                    <a:p>
-                      <a:r>
-                        <a:rPr sz="1300" b="0" i="0">
-                          <a:solidFill>
-                            <a:srgbClr val="232323"/>
-                          </a:solidFill>
-                          <a:latin typeface="Calibri"/>
-                        </a:rPr>
-                        <a:t>Full</a:t>
-                      </a:r>
-                    </a:p>
-                  </a:txBody>
-                  <a:tcPr marT="38100" marB="38100" anchor="ctr">
-                    <a:solidFill>
-                      <a:srgbClr val="FFFFFF"/>
-                    </a:solidFill>
-                  </a:tcPr>
-                </a:tc>
-                <a:tc>
-                  <a:txBody>
-                    <a:bodyPr/>
-                    <a:lstStyle/>
-                    <a:p>
-                      <a:r>
-                        <a:rPr sz="1300" b="0" i="0">
-                          <a:solidFill>
-                            <a:srgbClr val="232323"/>
-                          </a:solidFill>
-                          <a:latin typeface="Calibri"/>
-                        </a:rPr>
-                        <a:t>Directive 10 (high EE + RTS)</a:t>
-                      </a:r>
-                    </a:p>
-                  </a:txBody>
-                  <a:tcPr marT="38100" marB="38100" anchor="ctr">
-                    <a:solidFill>
-                      <a:srgbClr val="FFFFFF"/>
-                    </a:solidFill>
-                  </a:tcPr>
-                </a:tc>
-                <a:tc>
-                  <a:txBody>
-                    <a:bodyPr/>
-                    <a:lstStyle/>
-                    <a:p>
-                      <a:r>
-                        <a:rPr sz="1300" b="0" i="0">
-                          <a:solidFill>
-                            <a:srgbClr val="232323"/>
-                          </a:solidFill>
-                          <a:latin typeface="Calibri"/>
-                        </a:rPr>
-                        <a:t>0.190 / 0.227</a:t>
-                      </a:r>
-                    </a:p>
-                  </a:txBody>
-                  <a:tcPr marT="38100" marB="38100" anchor="ctr">
-                    <a:solidFill>
-                      <a:srgbClr val="FFFFFF"/>
-                    </a:solidFill>
-                  </a:tcPr>
-                </a:tc>
-                <a:tc>
-                  <a:txBody>
-                    <a:bodyPr/>
-                    <a:lstStyle/>
-                    <a:p>
-                      <a:r>
-                        <a:rPr sz="1300" b="0" i="0">
-                          <a:solidFill>
-                            <a:srgbClr val="232323"/>
-                          </a:solidFill>
-                          <a:latin typeface="Calibri"/>
-                        </a:rPr>
-                        <a:t>0.030 / 0.009</a:t>
-                      </a:r>
-                    </a:p>
-                  </a:txBody>
-                  <a:tcPr marT="38100" marB="38100" anchor="ctr">
-                    <a:solidFill>
-                      <a:srgbClr val="FFFFFF"/>
-                    </a:solidFill>
-                  </a:tcPr>
-                </a:tc>
-                <a:extLst>
-                  <a:ext uri="{0D108BD9-81ED-4DB2-BD59-A6C34878D82A}">
-                    <a16:rowId xmlns:a16="http://schemas.microsoft.com/office/drawing/2014/main" val="10003"/>
-                  </a:ext>
-                </a:extLst>
-              </a:tr>
-              <a:tr h="627017">
-                <a:tc>
-                  <a:txBody>
-                    <a:bodyPr/>
-                    <a:lstStyle/>
-                    <a:p>
-                      <a:r>
-                        <a:rPr sz="1300" b="1" i="0">
-                          <a:solidFill>
-                            <a:srgbClr val="232323"/>
-                          </a:solidFill>
-                          <a:latin typeface="Calibri"/>
-                        </a:rPr>
-                        <a:t>Group 2</a:t>
-                      </a:r>
-                    </a:p>
-                  </a:txBody>
-                  <a:tcPr marT="38100" marB="38100" anchor="ctr">
-                    <a:solidFill>
-                      <a:srgbClr val="F5F5F5"/>
-                    </a:solidFill>
-                  </a:tcPr>
-                </a:tc>
-                <a:tc>
-                  <a:txBody>
-                    <a:bodyPr/>
-                    <a:lstStyle/>
-                    <a:p>
-                      <a:r>
-                        <a:rPr sz="1300" b="1" i="0">
-                          <a:solidFill>
-                            <a:srgbClr val="232323"/>
-                          </a:solidFill>
-                          <a:latin typeface="Calibri"/>
-                        </a:rPr>
-                        <a:t>EE_Directive10_NoBESS</a:t>
-                      </a:r>
-                    </a:p>
-                  </a:txBody>
-                  <a:tcPr marT="38100" marB="38100" anchor="ctr">
-                    <a:solidFill>
-                      <a:srgbClr val="F5F5F5"/>
-                    </a:solidFill>
-                  </a:tcPr>
-                </a:tc>
-                <a:tc>
-                  <a:txBody>
-                    <a:bodyPr/>
-                    <a:lstStyle/>
-                    <a:p>
-                      <a:r>
-                        <a:rPr sz="1300" b="0" i="0">
-                          <a:solidFill>
-                            <a:srgbClr val="232323"/>
-                          </a:solidFill>
-                          <a:latin typeface="Calibri"/>
-                        </a:rPr>
-                        <a:t>NoBESS</a:t>
-                      </a:r>
-                    </a:p>
-                  </a:txBody>
-                  <a:tcPr marT="38100" marB="38100" anchor="ctr">
-                    <a:solidFill>
-                      <a:srgbClr val="F5F5F5"/>
-                    </a:solidFill>
-                  </a:tcPr>
-                </a:tc>
-                <a:tc>
-                  <a:txBody>
-                    <a:bodyPr/>
-                    <a:lstStyle/>
-                    <a:p>
-                      <a:r>
-                        <a:rPr sz="1300" b="0" i="0">
-                          <a:solidFill>
-                            <a:srgbClr val="232323"/>
-                          </a:solidFill>
-                          <a:latin typeface="Calibri"/>
-                        </a:rPr>
-                        <a:t>Directive 10 (high EE + RTS)</a:t>
-                      </a:r>
-                    </a:p>
-                  </a:txBody>
-                  <a:tcPr marT="38100" marB="38100" anchor="ctr">
-                    <a:solidFill>
-                      <a:srgbClr val="F5F5F5"/>
-                    </a:solidFill>
-                  </a:tcPr>
-                </a:tc>
-                <a:tc>
-                  <a:txBody>
-                    <a:bodyPr/>
-                    <a:lstStyle/>
-                    <a:p>
-                      <a:r>
-                        <a:rPr sz="1300" b="0" i="0" dirty="0">
-                          <a:solidFill>
-                            <a:srgbClr val="232323"/>
-                          </a:solidFill>
-                          <a:latin typeface="Calibri"/>
-                        </a:rPr>
-                        <a:t>0.190 / 0.227</a:t>
-                      </a:r>
-                    </a:p>
-                  </a:txBody>
-                  <a:tcPr marT="38100" marB="38100" anchor="ctr">
-                    <a:solidFill>
-                      <a:srgbClr val="F5F5F5"/>
-                    </a:solidFill>
-                  </a:tcPr>
-                </a:tc>
-                <a:tc>
-                  <a:txBody>
-                    <a:bodyPr/>
-                    <a:lstStyle/>
-                    <a:p>
-                      <a:r>
-                        <a:rPr sz="1300" b="0" i="0" dirty="0">
-                          <a:solidFill>
-                            <a:srgbClr val="232323"/>
-                          </a:solidFill>
-                          <a:latin typeface="Calibri"/>
-                        </a:rPr>
-                        <a:t>0.000 / 0.000</a:t>
-                      </a:r>
-                    </a:p>
-                  </a:txBody>
-                  <a:tcPr marT="38100" marB="38100" anchor="ctr">
-                    <a:solidFill>
-                      <a:srgbClr val="F5F5F5"/>
-                    </a:solidFill>
-                  </a:tcPr>
-                </a:tc>
-                <a:extLst>
-                  <a:ext uri="{0D108BD9-81ED-4DB2-BD59-A6C34878D82A}">
-                    <a16:rowId xmlns:a16="http://schemas.microsoft.com/office/drawing/2014/main" val="10004"/>
-                  </a:ext>
-                </a:extLst>
-              </a:tr>
-              <a:tr h="627017">
-                <a:tc>
-                  <a:txBody>
-                    <a:bodyPr/>
-                    <a:lstStyle/>
-                    <a:p>
-                      <a:r>
-                        <a:rPr sz="1300" b="1" i="0">
-                          <a:solidFill>
-                            <a:srgbClr val="232323"/>
-                          </a:solidFill>
-                          <a:latin typeface="Calibri"/>
-                        </a:rPr>
-                        <a:t>Group 3</a:t>
-                      </a:r>
-                    </a:p>
-                  </a:txBody>
-                  <a:tcPr marT="38100" marB="38100" anchor="ctr">
-                    <a:solidFill>
-                      <a:srgbClr val="FFFFFF"/>
-                    </a:solidFill>
-                  </a:tcPr>
-                </a:tc>
-                <a:tc>
-                  <a:txBody>
-                    <a:bodyPr/>
-                    <a:lstStyle/>
-                    <a:p>
-                      <a:r>
-                        <a:rPr sz="1300" b="1" i="0">
-                          <a:solidFill>
-                            <a:srgbClr val="232323"/>
-                          </a:solidFill>
-                          <a:latin typeface="Calibri"/>
-                        </a:rPr>
-                        <a:t>EE_PDP8_PV_BESS</a:t>
-                      </a:r>
-                    </a:p>
-                  </a:txBody>
-                  <a:tcPr marT="38100" marB="38100" anchor="ctr">
-                    <a:solidFill>
-                      <a:srgbClr val="FFFFFF"/>
-                    </a:solidFill>
-                  </a:tcPr>
-                </a:tc>
-                <a:tc>
-                  <a:txBody>
-                    <a:bodyPr/>
-                    <a:lstStyle/>
-                    <a:p>
-                      <a:r>
-                        <a:rPr sz="1300" b="0" i="0">
-                          <a:solidFill>
-                            <a:srgbClr val="232323"/>
-                          </a:solidFill>
-                          <a:latin typeface="Calibri"/>
-                        </a:rPr>
-                        <a:t>Full</a:t>
-                      </a:r>
-                    </a:p>
-                  </a:txBody>
-                  <a:tcPr marT="38100" marB="38100" anchor="ctr">
-                    <a:solidFill>
-                      <a:srgbClr val="FFFFFF"/>
-                    </a:solidFill>
-                  </a:tcPr>
-                </a:tc>
-                <a:tc>
-                  <a:txBody>
-                    <a:bodyPr/>
-                    <a:lstStyle/>
-                    <a:p>
-                      <a:r>
-                        <a:rPr sz="1300" b="0" i="0">
-                          <a:solidFill>
-                            <a:srgbClr val="232323"/>
-                          </a:solidFill>
-                          <a:latin typeface="Calibri"/>
-                        </a:rPr>
-                        <a:t>PDP8 + accelerated PV/BESS</a:t>
-                      </a:r>
-                    </a:p>
-                  </a:txBody>
-                  <a:tcPr marT="38100" marB="38100" anchor="ctr">
-                    <a:solidFill>
-                      <a:srgbClr val="FFFFFF"/>
-                    </a:solidFill>
-                  </a:tcPr>
-                </a:tc>
-                <a:tc>
-                  <a:txBody>
-                    <a:bodyPr/>
-                    <a:lstStyle/>
-                    <a:p>
-                      <a:r>
-                        <a:rPr sz="1300" b="0" i="0">
-                          <a:solidFill>
-                            <a:srgbClr val="232323"/>
-                          </a:solidFill>
-                          <a:latin typeface="Calibri"/>
-                        </a:rPr>
-                        <a:t>0.166 / 0.211</a:t>
-                      </a:r>
-                    </a:p>
-                  </a:txBody>
-                  <a:tcPr marT="38100" marB="38100" anchor="ctr">
-                    <a:solidFill>
-                      <a:srgbClr val="FFFFFF"/>
-                    </a:solidFill>
-                  </a:tcPr>
-                </a:tc>
-                <a:tc>
-                  <a:txBody>
-                    <a:bodyPr/>
-                    <a:lstStyle/>
-                    <a:p>
-                      <a:r>
-                        <a:rPr sz="1300" b="0" i="0">
-                          <a:solidFill>
-                            <a:srgbClr val="232323"/>
-                          </a:solidFill>
-                          <a:latin typeface="Calibri"/>
-                        </a:rPr>
-                        <a:t>0.049 / 0.014</a:t>
-                      </a:r>
-                    </a:p>
-                  </a:txBody>
-                  <a:tcPr marT="38100" marB="38100" anchor="ctr">
-                    <a:solidFill>
-                      <a:srgbClr val="FFFFFF"/>
-                    </a:solidFill>
-                  </a:tcPr>
-                </a:tc>
-                <a:extLst>
-                  <a:ext uri="{0D108BD9-81ED-4DB2-BD59-A6C34878D82A}">
-                    <a16:rowId xmlns:a16="http://schemas.microsoft.com/office/drawing/2014/main" val="10005"/>
-                  </a:ext>
-                </a:extLst>
-              </a:tr>
-              <a:tr h="627018">
-                <a:tc>
-                  <a:txBody>
-                    <a:bodyPr/>
-                    <a:lstStyle/>
-                    <a:p>
-                      <a:r>
-                        <a:rPr sz="1300" b="1" i="0">
-                          <a:solidFill>
-                            <a:srgbClr val="232323"/>
-                          </a:solidFill>
-                          <a:latin typeface="Calibri"/>
-                        </a:rPr>
-                        <a:t>Group 3</a:t>
-                      </a:r>
-                    </a:p>
-                  </a:txBody>
-                  <a:tcPr marT="38100" marB="38100" anchor="ctr">
-                    <a:solidFill>
-                      <a:srgbClr val="F5F5F5"/>
-                    </a:solidFill>
-                  </a:tcPr>
-                </a:tc>
-                <a:tc>
-                  <a:txBody>
-                    <a:bodyPr/>
-                    <a:lstStyle/>
-                    <a:p>
-                      <a:r>
-                        <a:rPr sz="1300" b="1" i="0">
-                          <a:solidFill>
-                            <a:srgbClr val="232323"/>
-                          </a:solidFill>
-                          <a:latin typeface="Calibri"/>
-                        </a:rPr>
-                        <a:t>EE_PDP8_PV_BESS_NoBESS</a:t>
-                      </a:r>
-                    </a:p>
-                  </a:txBody>
-                  <a:tcPr marT="38100" marB="38100" anchor="ctr">
-                    <a:solidFill>
-                      <a:srgbClr val="F5F5F5"/>
-                    </a:solidFill>
-                  </a:tcPr>
-                </a:tc>
-                <a:tc>
-                  <a:txBody>
-                    <a:bodyPr/>
-                    <a:lstStyle/>
-                    <a:p>
-                      <a:r>
-                        <a:rPr sz="1300" b="0" i="0">
-                          <a:solidFill>
-                            <a:srgbClr val="232323"/>
-                          </a:solidFill>
-                          <a:latin typeface="Calibri"/>
-                        </a:rPr>
-                        <a:t>NoBESS</a:t>
-                      </a:r>
-                    </a:p>
-                  </a:txBody>
-                  <a:tcPr marT="38100" marB="38100" anchor="ctr">
-                    <a:solidFill>
-                      <a:srgbClr val="F5F5F5"/>
-                    </a:solidFill>
-                  </a:tcPr>
-                </a:tc>
-                <a:tc>
-                  <a:txBody>
-                    <a:bodyPr/>
-                    <a:lstStyle/>
-                    <a:p>
-                      <a:r>
-                        <a:rPr sz="1300" b="0" i="0">
-                          <a:solidFill>
-                            <a:srgbClr val="232323"/>
-                          </a:solidFill>
-                          <a:latin typeface="Calibri"/>
-                        </a:rPr>
-                        <a:t>PDP8 + accelerated PV/BESS</a:t>
-                      </a:r>
-                    </a:p>
-                  </a:txBody>
-                  <a:tcPr marT="38100" marB="38100" anchor="ctr">
-                    <a:solidFill>
-                      <a:srgbClr val="F5F5F5"/>
-                    </a:solidFill>
-                  </a:tcPr>
-                </a:tc>
-                <a:tc>
-                  <a:txBody>
-                    <a:bodyPr/>
-                    <a:lstStyle/>
-                    <a:p>
-                      <a:r>
-                        <a:rPr sz="1300" b="0" i="0" dirty="0">
-                          <a:solidFill>
-                            <a:srgbClr val="232323"/>
-                          </a:solidFill>
-                          <a:latin typeface="Calibri"/>
-                        </a:rPr>
-                        <a:t>0.166 / 0.211</a:t>
-                      </a:r>
-                    </a:p>
-                  </a:txBody>
-                  <a:tcPr marT="38100" marB="38100" anchor="ctr">
-                    <a:solidFill>
-                      <a:srgbClr val="F5F5F5"/>
-                    </a:solidFill>
-                  </a:tcPr>
-                </a:tc>
-                <a:tc>
-                  <a:txBody>
-                    <a:bodyPr/>
-                    <a:lstStyle/>
-                    <a:p>
-                      <a:r>
-                        <a:rPr sz="1300" b="0" i="0" dirty="0">
-                          <a:solidFill>
-                            <a:srgbClr val="232323"/>
-                          </a:solidFill>
-                          <a:latin typeface="Calibri"/>
-                        </a:rPr>
-                        <a:t>0.000 / 0.000</a:t>
-                      </a:r>
-                    </a:p>
-                  </a:txBody>
-                  <a:tcPr marT="38100" marB="38100" anchor="ctr">
-                    <a:solidFill>
-                      <a:srgbClr val="F5F5F5"/>
-                    </a:solidFill>
-                  </a:tcPr>
-                </a:tc>
-                <a:extLst>
-                  <a:ext uri="{0D108BD9-81ED-4DB2-BD59-A6C34878D82A}">
-                    <a16:rowId xmlns:a16="http://schemas.microsoft.com/office/drawing/2014/main" val="10006"/>
-                  </a:ext>
-                </a:extLst>
-              </a:tr>
-            </a:tbl>
-          </a:graphicData>
-        </a:graphic>
-      </p:graphicFrame>
-      <p:sp>
-        <p:nvSpPr>
-          <p:cNvPr id="10" name="Rounded Rectangle 9"/>
-          <p:cNvSpPr/>
-          <p:nvPr/>
-        </p:nvSpPr>
-        <p:spPr>
-          <a:xfrm>
-            <a:off x="502920" y="5870448"/>
-            <a:ext cx="11185855" cy="640080"/>
-          </a:xfrm>
-          <a:prstGeom prst="roundRect">
-            <a:avLst/>
-          </a:prstGeom>
-          <a:solidFill>
-            <a:srgbClr val="F5F5F5"/>
-          </a:solidFill>
-          <a:ln w="12700">
-            <a:solidFill>
-              <a:srgbClr val="CC071E"/>
-            </a:solidFill>
-          </a:ln>
-          <a:effectLst/>
-        </p:spPr>
-        <p:style>
-          <a:lnRef idx="1">
-            <a:schemeClr val="accent1"/>
-          </a:lnRef>
-          <a:fillRef idx="3">
-            <a:schemeClr val="accent1"/>
-          </a:fillRef>
-          <a:effectRef idx="2">
-            <a:schemeClr val="accent1"/>
-          </a:effectRef>
-          <a:fontRef idx="minor">
-            <a:schemeClr val="lt1"/>
-          </a:fontRef>
-        </p:style>
-        <p:txBody>
-          <a:bodyPr wrap="square" lIns="137160" tIns="54864" rIns="137160" bIns="54864" rtlCol="0" anchor="ctr"/>
-          <a:lstStyle/>
-          <a:p>
-            <a:pPr algn="ctr"/>
-            <a:r>
-              <a:rPr sz="1300" b="0" i="1">
+        </p:nvSpPr>
+        <p:spPr>
+          <a:xfrm>
+            <a:off x="502920" y="1554480"/>
+            <a:ext cx="11185855" cy="1785104"/>
+          </a:xfrm>
+          <a:prstGeom prst="rect">
+            <a:avLst/>
+          </a:prstGeom>
+          <a:noFill/>
+        </p:spPr>
+        <p:txBody>
+          <a:bodyPr wrap="square">
+            <a:spAutoFit/>
+          </a:bodyPr>
+          <a:lstStyle/>
+          <a:p>
+            <a:pPr marL="0" indent="0">
+              <a:spcAft>
+                <a:spcPts val="1000"/>
+              </a:spcAft>
+            </a:pPr>
+            <a:r>
+              <a:rPr sz="1700" b="0" i="0" dirty="0">
                 <a:solidFill>
                   <a:srgbClr val="232323"/>
                 </a:solidFill>
                 <a:latin typeface="Calibri"/>
               </a:rPr>
-              <a:t>exo_AI = industry/services productivity index (EE + rooftop-PV demand reduction). EE_PDP8's BESS channel is zero throughout, so Full = NoBESS there. Compare Full vs NoBESS only within the SAME group.</a:t>
+              <a:t>•  Same rigor as the finance sheet: mechanism, sector-specific assumptions (with source), affected sectors, time path, expected effects — including the rebound effect — key output indicators, caveats</a:t>
+            </a:r>
+          </a:p>
+          <a:p>
+            <a:pPr marL="0" indent="0">
+              <a:spcAft>
+                <a:spcPts val="1000"/>
+              </a:spcAft>
+            </a:pPr>
+            <a:r>
+              <a:rPr sz="1700" b="0" i="0" dirty="0">
+                <a:solidFill>
+                  <a:srgbClr val="232323"/>
+                </a:solidFill>
+                <a:latin typeface="Calibri"/>
+              </a:rPr>
+              <a:t>•  Each group documents both BESS variants for its assigned family, not only one variant</a:t>
+            </a:r>
+          </a:p>
+          <a:p>
+            <a:pPr marL="0" indent="0">
+              <a:spcAft>
+                <a:spcPts val="1000"/>
+              </a:spcAft>
+            </a:pPr>
+            <a:r>
+              <a:rPr sz="1700" b="0" i="0" dirty="0">
+                <a:solidFill>
+                  <a:srgbClr val="232323"/>
+                </a:solidFill>
+                <a:latin typeface="Calibri"/>
+              </a:rPr>
+              <a:t>•  Affected sectors: manufacturing, services/commercial, households</a:t>
+            </a:r>
+            <a:endParaRPr lang="en-US" sz="1700" b="0" i="0" dirty="0">
+              <a:solidFill>
+                <a:srgbClr val="232323"/>
+              </a:solidFill>
+              <a:latin typeface="Calibri"/>
+            </a:endParaRPr>
+          </a:p>
+          <a:p>
+            <a:pPr marL="0" indent="0">
+              <a:spcAft>
+                <a:spcPts val="1000"/>
+              </a:spcAft>
+            </a:pPr>
+            <a:r>
+              <a:rPr sz="1700" b="0" i="0">
+                <a:solidFill>
+                  <a:srgbClr val="232323"/>
+                </a:solidFill>
+                <a:latin typeface="Calibri"/>
+              </a:rPr>
+              <a:t>•  </a:t>
+            </a:r>
+            <a:r>
+              <a:rPr sz="1700" b="0" i="0" dirty="0">
+                <a:solidFill>
+                  <a:srgbClr val="232323"/>
+                </a:solidFill>
+                <a:latin typeface="Calibri"/>
+              </a:rPr>
+              <a:t>Record your sheet in the energy-efficiency scenario log before the session ends</a:t>
             </a:r>
           </a:p>
         </p:txBody>
@@ -5396,7 +4457,7 @@
                 </a:solidFill>
                 <a:latin typeface="Calibri"/>
               </a:rPr>
-              <a:t>BLOCK 7 · 30 MIN</a:t>
+              <a:t>WRAP-UP</a:t>
             </a:r>
           </a:p>
           <a:p>
@@ -5407,7 +4468,7 @@
                 </a:solidFill>
                 <a:latin typeface="Calibri"/>
               </a:rPr>
-              <a:t>Draft Your Energy-Efficiency Scenario Metadata Sheet</a:t>
+              <a:t>Debrief &amp; Common Errors</a:t>
             </a:r>
           </a:p>
         </p:txBody>
@@ -5584,7 +4645,7 @@
                 </a:solidFill>
                 <a:latin typeface="Calibri"/>
               </a:rPr>
-              <a:t>•  Your group is assigned one of the three EE scenario families — Group 1 = EE_PDP8, Group 2 = EE_Directive10, Group 3 = EE_PDP8_PV_BESS — cover both the Full and NoBESS variant for your family</a:t>
+              <a:t>•  Debrief: for your finance scenario, which of r_G, r_FDI, K_G share, and K_FDI share differ vs. the structure you compare against?</a:t>
             </a:r>
           </a:p>
           <a:p>
@@ -5600,7 +4661,7 @@
                 </a:solidFill>
                 <a:latin typeface="Calibri"/>
               </a:rPr>
-              <a:t>•  Same rigor as the finance sheet: mechanism, sector-specific assumptions (with source), affected sectors, time path, expected effects — including the rebound effect — key output indicators, caveats</a:t>
+              <a:t>•  Debrief: what does the rebound effect do to the efficiency scenario's net savings?</a:t>
             </a:r>
           </a:p>
           <a:p>
@@ -5616,7 +4677,7 @@
                 </a:solidFill>
                 <a:latin typeface="Calibri"/>
               </a:rPr>
-              <a:t>•  Affected sectors: manufacturing, services/commercial, households</a:t>
+              <a:t>•  Watch out for: confusing the calibrated baseline with PDP8_GF_B — Group B is still a financing structure, not the no-shock reference case</a:t>
             </a:r>
           </a:p>
           <a:p>
@@ -5626,13 +4687,13 @@
               </a:spcAft>
             </a:pPr>
             <a:r>
-              <a:rPr sz="1700" b="1" i="0">
+              <a:rPr sz="1700" b="0" i="0">
                 <a:solidFill>
                   <a:srgbClr val="232323"/>
                 </a:solidFill>
                 <a:latin typeface="Calibri"/>
               </a:rPr>
-              <a:t>•  Cite every numeric value; mark anything not in energy_efficiency_pathway.md as [SME REVIEW NEEDED]</a:t>
+              <a:t>•  Watch out for: comparing across emissions pathways by mistake — same-pathway comparison only</a:t>
             </a:r>
           </a:p>
           <a:p>
@@ -5648,7 +4709,7 @@
                 </a:solidFill>
                 <a:latin typeface="Calibri"/>
               </a:rPr>
-              <a:t>•  Record your sheet in the energy-efficiency scenario log before the session ends</a:t>
+              <a:t>•  Watch out for: leaving the rebound effect out of the efficiency scenario's expected-effects field</a:t>
             </a:r>
           </a:p>
         </p:txBody>
@@ -5802,7 +4863,7 @@
                 </a:solidFill>
                 <a:latin typeface="Calibri"/>
               </a:rPr>
-              <a:t>WRAP-UP</a:t>
+              <a:t>BLOCK 8 · 5 MIN</a:t>
             </a:r>
           </a:p>
           <a:p>
@@ -5813,7 +4874,7 @@
                 </a:solidFill>
                 <a:latin typeface="Calibri"/>
               </a:rPr>
-              <a:t>Debrief &amp; Common Errors</a:t>
+              <a:t>Today's Output &amp; What's Next</a:t>
             </a:r>
           </a:p>
         </p:txBody>
@@ -5952,549 +5013,6 @@
                 <a:latin typeface="Calibri"/>
               </a:rPr>
               <a:t>12</a:t>
-            </a:r>
-          </a:p>
-        </p:txBody>
-      </p:sp>
-      <p:sp>
-        <p:nvSpPr>
-          <p:cNvPr id="9" name="TextBox 8"/>
-          <p:cNvSpPr txBox="1"/>
-          <p:nvPr/>
-        </p:nvSpPr>
-        <p:spPr>
-          <a:xfrm>
-            <a:off x="502920" y="1554480"/>
-            <a:ext cx="11185855" cy="3734356"/>
-          </a:xfrm>
-          <a:prstGeom prst="rect">
-            <a:avLst/>
-          </a:prstGeom>
-          <a:noFill/>
-        </p:spPr>
-        <p:txBody>
-          <a:bodyPr wrap="square">
-            <a:spAutoFit/>
-          </a:bodyPr>
-          <a:lstStyle/>
-          <a:p>
-            <a:pPr marL="0" indent="0">
-              <a:spcAft>
-                <a:spcPts val="1000"/>
-              </a:spcAft>
-            </a:pPr>
-            <a:r>
-              <a:rPr sz="1700" b="0" i="0" dirty="0">
-                <a:solidFill>
-                  <a:srgbClr val="232323"/>
-                </a:solidFill>
-                <a:latin typeface="Calibri"/>
-              </a:rPr>
-              <a:t>•  Debrief: for your finance scenario, what's the one variable that changes vs. its base </a:t>
-            </a:r>
-            <a:r>
-              <a:rPr sz="1700" b="0" i="0">
-                <a:solidFill>
-                  <a:srgbClr val="232323"/>
-                </a:solidFill>
-                <a:latin typeface="Calibri"/>
-              </a:rPr>
-              <a:t>case?</a:t>
-            </a:r>
-            <a:endParaRPr lang="en-US" sz="1700" b="0" i="0">
-              <a:solidFill>
-                <a:srgbClr val="232323"/>
-              </a:solidFill>
-              <a:latin typeface="Calibri"/>
-            </a:endParaRPr>
-          </a:p>
-          <a:p>
-            <a:pPr marL="0" indent="0">
-              <a:spcAft>
-                <a:spcPts val="1000"/>
-              </a:spcAft>
-            </a:pPr>
-            <a:endParaRPr sz="1700" b="0" i="0" dirty="0">
-              <a:solidFill>
-                <a:srgbClr val="232323"/>
-              </a:solidFill>
-              <a:latin typeface="Calibri"/>
-            </a:endParaRPr>
-          </a:p>
-          <a:p>
-            <a:pPr marL="0" indent="0">
-              <a:spcAft>
-                <a:spcPts val="1000"/>
-              </a:spcAft>
-            </a:pPr>
-            <a:r>
-              <a:rPr sz="1700" b="0" i="0" dirty="0">
-                <a:solidFill>
-                  <a:srgbClr val="232323"/>
-                </a:solidFill>
-                <a:latin typeface="Calibri"/>
-              </a:rPr>
-              <a:t>•  Debrief: what does the rebound effect do to the efficiency scenario's net savings?</a:t>
-            </a:r>
-            <a:endParaRPr lang="en-US" sz="1700" b="0" i="0" dirty="0">
-              <a:solidFill>
-                <a:srgbClr val="232323"/>
-              </a:solidFill>
-              <a:latin typeface="Calibri"/>
-            </a:endParaRPr>
-          </a:p>
-          <a:p>
-            <a:pPr marL="0" indent="0">
-              <a:spcAft>
-                <a:spcPts val="1000"/>
-              </a:spcAft>
-            </a:pPr>
-            <a:endParaRPr sz="1700" b="0" i="0" dirty="0">
-              <a:solidFill>
-                <a:srgbClr val="232323"/>
-              </a:solidFill>
-              <a:latin typeface="Calibri"/>
-            </a:endParaRPr>
-          </a:p>
-          <a:p>
-            <a:pPr marL="0" indent="0">
-              <a:spcAft>
-                <a:spcPts val="1000"/>
-              </a:spcAft>
-            </a:pPr>
-            <a:r>
-              <a:rPr sz="1700" b="0" i="0" dirty="0">
-                <a:solidFill>
-                  <a:srgbClr val="232323"/>
-                </a:solidFill>
-                <a:latin typeface="Calibri"/>
-              </a:rPr>
-              <a:t>•  Watch out for: confusing the calibrated Baseline with PDP8_GF_B — GF_B is still a financing shock (market-led: </a:t>
-            </a:r>
-            <a:r>
-              <a:rPr sz="1700" b="0" i="0" dirty="0" err="1">
-                <a:solidFill>
-                  <a:srgbClr val="232323"/>
-                </a:solidFill>
-                <a:latin typeface="Calibri"/>
-              </a:rPr>
-              <a:t>r_G</a:t>
-            </a:r>
-            <a:r>
-              <a:rPr sz="1700" b="0" i="0" dirty="0">
-                <a:solidFill>
-                  <a:srgbClr val="232323"/>
-                </a:solidFill>
-                <a:latin typeface="Calibri"/>
-              </a:rPr>
-              <a:t> 7.37%, </a:t>
-            </a:r>
-            <a:r>
-              <a:rPr sz="1700" b="0" i="0" dirty="0" err="1">
-                <a:solidFill>
-                  <a:srgbClr val="232323"/>
-                </a:solidFill>
-                <a:latin typeface="Calibri"/>
-              </a:rPr>
-              <a:t>r_FDI</a:t>
-            </a:r>
-            <a:r>
-              <a:rPr sz="1700" b="0" i="0" dirty="0">
-                <a:solidFill>
-                  <a:srgbClr val="232323"/>
-                </a:solidFill>
-                <a:latin typeface="Calibri"/>
-              </a:rPr>
-              <a:t> 6.90%), just the closest to current practice</a:t>
-            </a:r>
-            <a:endParaRPr lang="en-US" sz="1700" b="0" i="0" dirty="0">
-              <a:solidFill>
-                <a:srgbClr val="232323"/>
-              </a:solidFill>
-              <a:latin typeface="Calibri"/>
-            </a:endParaRPr>
-          </a:p>
-          <a:p>
-            <a:pPr marL="0" indent="0">
-              <a:spcAft>
-                <a:spcPts val="1000"/>
-              </a:spcAft>
-            </a:pPr>
-            <a:endParaRPr sz="1700" b="0" i="0" dirty="0">
-              <a:solidFill>
-                <a:srgbClr val="232323"/>
-              </a:solidFill>
-              <a:latin typeface="Calibri"/>
-            </a:endParaRPr>
-          </a:p>
-          <a:p>
-            <a:pPr marL="0" indent="0">
-              <a:spcAft>
-                <a:spcPts val="1000"/>
-              </a:spcAft>
-            </a:pPr>
-            <a:r>
-              <a:rPr sz="1700" b="0" i="0" dirty="0">
-                <a:solidFill>
-                  <a:srgbClr val="232323"/>
-                </a:solidFill>
-                <a:latin typeface="Calibri"/>
-              </a:rPr>
-              <a:t>•  Watch out for: comparing across emissions pathways by mistake — same-pathway comparison only</a:t>
-            </a:r>
-            <a:endParaRPr lang="en-US" sz="1700" b="0" i="0" dirty="0">
-              <a:solidFill>
-                <a:srgbClr val="232323"/>
-              </a:solidFill>
-              <a:latin typeface="Calibri"/>
-            </a:endParaRPr>
-          </a:p>
-          <a:p>
-            <a:pPr marL="0" indent="0">
-              <a:spcAft>
-                <a:spcPts val="1000"/>
-              </a:spcAft>
-            </a:pPr>
-            <a:endParaRPr sz="1700" b="0" i="0" dirty="0">
-              <a:solidFill>
-                <a:srgbClr val="232323"/>
-              </a:solidFill>
-              <a:latin typeface="Calibri"/>
-            </a:endParaRPr>
-          </a:p>
-          <a:p>
-            <a:pPr marL="0" indent="0">
-              <a:spcAft>
-                <a:spcPts val="1000"/>
-              </a:spcAft>
-            </a:pPr>
-            <a:r>
-              <a:rPr sz="1700" b="0" i="0" dirty="0">
-                <a:solidFill>
-                  <a:srgbClr val="232323"/>
-                </a:solidFill>
-                <a:latin typeface="Calibri"/>
-              </a:rPr>
-              <a:t>•  Watch out for: leaving the rebound effect out of the efficiency scenario's expected-effects field</a:t>
-            </a:r>
-          </a:p>
-          <a:p>
-            <a:pPr marL="0" indent="0">
-              <a:spcAft>
-                <a:spcPts val="1000"/>
-              </a:spcAft>
-            </a:pPr>
-            <a:r>
-              <a:rPr sz="1700" b="0" i="0" dirty="0">
-                <a:solidFill>
-                  <a:srgbClr val="232323"/>
-                </a:solidFill>
-                <a:latin typeface="Calibri"/>
-              </a:rPr>
-              <a:t>•  Watch out for: expecting a difference between EE_PDP8 and EE_PDP8_NoBESS — that BESS channel is zero throughout, so the two are numerically identical (the real BESS effect shows up in Group 2/3)</a:t>
-            </a:r>
-          </a:p>
-        </p:txBody>
-      </p:sp>
-    </p:spTree>
-  </p:cSld>
-  <p:clrMapOvr>
-    <a:masterClrMapping/>
-  </p:clrMapOvr>
-</p:sld>
-</file>
-
-<file path=ppt/slides/slide14.xml><?xml version="1.0" encoding="utf-8"?>
-<p:sld xmlns:a="http://schemas.openxmlformats.org/drawingml/2006/main" xmlns:r="http://schemas.openxmlformats.org/officeDocument/2006/relationships" xmlns:p="http://schemas.openxmlformats.org/presentationml/2006/main">
-  <p:cSld>
-    <p:spTree>
-      <p:nvGrpSpPr>
-        <p:cNvPr id="1" name=""/>
-        <p:cNvGrpSpPr/>
-        <p:nvPr/>
-      </p:nvGrpSpPr>
-      <p:grpSpPr>
-        <a:xfrm>
-          <a:off x="0" y="0"/>
-          <a:ext cx="0" cy="0"/>
-          <a:chOff x="0" y="0"/>
-          <a:chExt cx="0" cy="0"/>
-        </a:xfrm>
-      </p:grpSpPr>
-      <p:sp>
-        <p:nvSpPr>
-          <p:cNvPr id="2" name="Rectangle 1"/>
-          <p:cNvSpPr/>
-          <p:nvPr/>
-        </p:nvSpPr>
-        <p:spPr>
-          <a:xfrm>
-            <a:off x="0" y="0"/>
-            <a:ext cx="12191695" cy="6858000"/>
-          </a:xfrm>
-          <a:prstGeom prst="rect">
-            <a:avLst/>
-          </a:prstGeom>
-          <a:solidFill>
-            <a:srgbClr val="FFFFFF"/>
-          </a:solidFill>
-          <a:ln>
-            <a:noFill/>
-          </a:ln>
-          <a:effectLst/>
-        </p:spPr>
-        <p:style>
-          <a:lnRef idx="1">
-            <a:schemeClr val="accent1"/>
-          </a:lnRef>
-          <a:fillRef idx="3">
-            <a:schemeClr val="accent1"/>
-          </a:fillRef>
-          <a:effectRef idx="2">
-            <a:schemeClr val="accent1"/>
-          </a:effectRef>
-          <a:fontRef idx="minor">
-            <a:schemeClr val="lt1"/>
-          </a:fontRef>
-        </p:style>
-        <p:txBody>
-          <a:bodyPr rtlCol="0" anchor="ctr"/>
-          <a:lstStyle/>
-          <a:p>
-            <a:pPr algn="ctr"/>
-            <a:endParaRPr/>
-          </a:p>
-        </p:txBody>
-      </p:sp>
-      <p:sp>
-        <p:nvSpPr>
-          <p:cNvPr id="3" name="Rectangle 2"/>
-          <p:cNvSpPr/>
-          <p:nvPr/>
-        </p:nvSpPr>
-        <p:spPr>
-          <a:xfrm>
-            <a:off x="0" y="0"/>
-            <a:ext cx="12191695" cy="1280160"/>
-          </a:xfrm>
-          <a:prstGeom prst="rect">
-            <a:avLst/>
-          </a:prstGeom>
-          <a:solidFill>
-            <a:srgbClr val="CC071E"/>
-          </a:solidFill>
-          <a:ln>
-            <a:noFill/>
-          </a:ln>
-          <a:effectLst/>
-        </p:spPr>
-        <p:style>
-          <a:lnRef idx="1">
-            <a:schemeClr val="accent1"/>
-          </a:lnRef>
-          <a:fillRef idx="3">
-            <a:schemeClr val="accent1"/>
-          </a:fillRef>
-          <a:effectRef idx="2">
-            <a:schemeClr val="accent1"/>
-          </a:effectRef>
-          <a:fontRef idx="minor">
-            <a:schemeClr val="lt1"/>
-          </a:fontRef>
-        </p:style>
-        <p:txBody>
-          <a:bodyPr rtlCol="0" anchor="ctr"/>
-          <a:lstStyle/>
-          <a:p>
-            <a:pPr algn="ctr"/>
-            <a:endParaRPr/>
-          </a:p>
-        </p:txBody>
-      </p:sp>
-      <p:sp>
-        <p:nvSpPr>
-          <p:cNvPr id="4" name="TextBox 3"/>
-          <p:cNvSpPr txBox="1"/>
-          <p:nvPr/>
-        </p:nvSpPr>
-        <p:spPr>
-          <a:xfrm>
-            <a:off x="502920" y="91440"/>
-            <a:ext cx="8778240" cy="1097280"/>
-          </a:xfrm>
-          <a:prstGeom prst="rect">
-            <a:avLst/>
-          </a:prstGeom>
-          <a:noFill/>
-        </p:spPr>
-        <p:txBody>
-          <a:bodyPr wrap="square" anchor="ctr">
-            <a:spAutoFit/>
-          </a:bodyPr>
-          <a:lstStyle/>
-          <a:p>
-            <a:pPr>
-              <a:spcAft>
-                <a:spcPts val="1400"/>
-              </a:spcAft>
-            </a:pPr>
-            <a:r>
-              <a:rPr sz="1100" b="1" i="0">
-                <a:solidFill>
-                  <a:srgbClr val="FFD2D2"/>
-                </a:solidFill>
-                <a:latin typeface="Calibri"/>
-              </a:rPr>
-              <a:t>BLOCK 8 · 5 MIN</a:t>
-            </a:r>
-          </a:p>
-          <a:p>
-            <a:r>
-              <a:rPr sz="2400" b="1" i="0">
-                <a:solidFill>
-                  <a:srgbClr val="FFFFFF"/>
-                </a:solidFill>
-                <a:latin typeface="Calibri"/>
-              </a:rPr>
-              <a:t>Today's Output &amp; What's Next</a:t>
-            </a:r>
-          </a:p>
-        </p:txBody>
-      </p:sp>
-      <p:pic>
-        <p:nvPicPr>
-          <p:cNvPr id="5" name="Picture 4" descr="GIZ_Logo.png"/>
-          <p:cNvPicPr>
-            <a:picLocks noChangeAspect="1"/>
-          </p:cNvPicPr>
-          <p:nvPr/>
-        </p:nvPicPr>
-        <p:blipFill>
-          <a:blip r:embed="rId2"/>
-          <a:stretch>
-            <a:fillRect/>
-          </a:stretch>
-        </p:blipFill>
-        <p:spPr>
-          <a:xfrm>
-            <a:off x="10454335" y="420624"/>
-            <a:ext cx="1590261" cy="438912"/>
-          </a:xfrm>
-          <a:prstGeom prst="rect">
-            <a:avLst/>
-          </a:prstGeom>
-        </p:spPr>
-      </p:pic>
-      <p:sp>
-        <p:nvSpPr>
-          <p:cNvPr id="6" name="Rectangle 5"/>
-          <p:cNvSpPr/>
-          <p:nvPr/>
-        </p:nvSpPr>
-        <p:spPr>
-          <a:xfrm>
-            <a:off x="0" y="6565392"/>
-            <a:ext cx="12191695" cy="292608"/>
-          </a:xfrm>
-          <a:prstGeom prst="rect">
-            <a:avLst/>
-          </a:prstGeom>
-          <a:solidFill>
-            <a:srgbClr val="FFFFFF"/>
-          </a:solidFill>
-          <a:ln>
-            <a:noFill/>
-          </a:ln>
-          <a:effectLst/>
-        </p:spPr>
-        <p:style>
-          <a:lnRef idx="1">
-            <a:schemeClr val="accent1"/>
-          </a:lnRef>
-          <a:fillRef idx="3">
-            <a:schemeClr val="accent1"/>
-          </a:fillRef>
-          <a:effectRef idx="2">
-            <a:schemeClr val="accent1"/>
-          </a:effectRef>
-          <a:fontRef idx="minor">
-            <a:schemeClr val="lt1"/>
-          </a:fontRef>
-        </p:style>
-        <p:txBody>
-          <a:bodyPr rtlCol="0" anchor="ctr"/>
-          <a:lstStyle/>
-          <a:p>
-            <a:pPr algn="ctr"/>
-            <a:endParaRPr/>
-          </a:p>
-        </p:txBody>
-      </p:sp>
-      <p:sp>
-        <p:nvSpPr>
-          <p:cNvPr id="7" name="TextBox 6"/>
-          <p:cNvSpPr txBox="1"/>
-          <p:nvPr/>
-        </p:nvSpPr>
-        <p:spPr>
-          <a:xfrm>
-            <a:off x="457200" y="6547104"/>
-            <a:ext cx="7315200" cy="274320"/>
-          </a:xfrm>
-          <a:prstGeom prst="rect">
-            <a:avLst/>
-          </a:prstGeom>
-          <a:noFill/>
-        </p:spPr>
-        <p:txBody>
-          <a:bodyPr wrap="none" tIns="0" bIns="0">
-            <a:spAutoFit/>
-          </a:bodyPr>
-          <a:lstStyle/>
-          <a:p>
-            <a:r>
-              <a:rPr sz="1000" b="0" i="0">
-                <a:solidFill>
-                  <a:srgbClr val="787878"/>
-                </a:solidFill>
-                <a:latin typeface="Calibri"/>
-              </a:rPr>
-              <a:t>DGE-METRIC Online Training — Online Day 1 — Wed 22 Jul 2026</a:t>
-            </a:r>
-          </a:p>
-        </p:txBody>
-      </p:sp>
-      <p:sp>
-        <p:nvSpPr>
-          <p:cNvPr id="8" name="TextBox 7"/>
-          <p:cNvSpPr txBox="1"/>
-          <p:nvPr/>
-        </p:nvSpPr>
-        <p:spPr>
-          <a:xfrm>
-            <a:off x="11002975" y="6547104"/>
-            <a:ext cx="822960" cy="274320"/>
-          </a:xfrm>
-          <a:prstGeom prst="rect">
-            <a:avLst/>
-          </a:prstGeom>
-          <a:noFill/>
-        </p:spPr>
-        <p:txBody>
-          <a:bodyPr wrap="none" tIns="0">
-            <a:spAutoFit/>
-          </a:bodyPr>
-          <a:lstStyle/>
-          <a:p>
-            <a:pPr algn="r"/>
-            <a:r>
-              <a:rPr sz="1000" b="0" i="0">
-                <a:solidFill>
-                  <a:srgbClr val="787878"/>
-                </a:solidFill>
-                <a:latin typeface="Calibri"/>
-              </a:rPr>
-              <a:t>13</a:t>
             </a:r>
           </a:p>
         </p:txBody>
@@ -7219,7 +5737,7 @@
                           </a:solidFill>
                           <a:latin typeface="Calibri"/>
                         </a:rPr>
-                        <a:t>4. The six-scenario finance matrix, in full</a:t>
+                        <a:t>4. The finance matrix, in full</a:t>
                       </a:r>
                     </a:p>
                   </a:txBody>
@@ -7263,7 +5781,7 @@
                           </a:solidFill>
                           <a:latin typeface="Calibri"/>
                         </a:rPr>
-                        <a:t>Balanced, market-led, and public-led financing structures (Group 1 = A, Group 2 = B, Group 3 = C) x PDP8/NZ pathway, mechanism by mechanism</a:t>
+                        <a:t>Three financing structures across PDP8 and Net Zero, mechanism by mechanism</a:t>
                       </a:r>
                     </a:p>
                   </a:txBody>
@@ -7336,7 +5854,7 @@
                           </a:solidFill>
                           <a:latin typeface="Calibri"/>
                         </a:rPr>
-                        <a:t>Each of the 3 groups documents its assigned financing structure (both pathway variants) in full</a:t>
+                        <a:t>Groups document their assigned scenario in full</a:t>
                       </a:r>
                     </a:p>
                   </a:txBody>
@@ -7474,7 +5992,7 @@
                           </a:solidFill>
                           <a:latin typeface="Calibri"/>
                         </a:rPr>
-                        <a:t>Narrative and core channels, then the three-family EE matrix (Group 1 = EE_PDP8, Group 2 = Directive10, Group 3 = PV/BESS) x Full/NoBESS</a:t>
+                        <a:t>Narrative, core channels, 2030 savings potential, investment need, rebound effect</a:t>
                       </a:r>
                     </a:p>
                   </a:txBody>
@@ -7547,7 +6065,7 @@
                           </a:solidFill>
                           <a:latin typeface="Calibri"/>
                         </a:rPr>
-                        <a:t>Each of the 3 groups documents its assigned EE family (both BESS variants) using the same rigor</a:t>
+                        <a:t>Groups document the efficiency scenario using the same rigor</a:t>
                       </a:r>
                     </a:p>
                   </a:txBody>
@@ -8393,32 +6911,13 @@
               </a:spcAft>
             </a:pPr>
             <a:r>
-              <a:rPr sz="1700" b="0">
+              <a:rPr sz="1700" b="0" i="0">
                 <a:solidFill>
                   <a:srgbClr val="232323"/>
                 </a:solidFill>
                 <a:latin typeface="Calibri"/>
               </a:rPr>
-              <a:t>•  VS Code: download from </a:t>
-            </a:r>
-            <a:r>
-              <a:rPr sz="1700" b="0" u="sng">
-                <a:solidFill>
-                  <a:srgbClr val="0563C1"/>
-                </a:solidFill>
-                <a:latin typeface="Calibri"/>
-                <a:hlinkClick r:id="rId3"/>
-              </a:rPr>
-              <a:t>code.visualstudio.com</a:t>
-            </a:r>
-            <a:r>
-              <a:rPr sz="1700" b="0">
-                <a:solidFill>
-                  <a:srgbClr val="232323"/>
-                </a:solidFill>
-                <a:latin typeface="Calibri"/>
-              </a:rPr>
-              <a:t>, open once to confirm it launches</a:t>
+              <a:t>•  VS Code: download from code.visualstudio.com, open once to confirm it launches</a:t>
             </a:r>
           </a:p>
           <a:p>
@@ -8428,23 +6927,13 @@
               </a:spcAft>
             </a:pPr>
             <a:r>
-              <a:rPr sz="1700" b="0">
+              <a:rPr sz="1700" b="0" i="0">
                 <a:solidFill>
                   <a:srgbClr val="232323"/>
                 </a:solidFill>
                 <a:latin typeface="Calibri"/>
               </a:rPr>
-              <a:t>•  GitHub: create a free account at </a:t>
-            </a:r>
-            <a:r>
-              <a:rPr sz="1700" b="0" u="sng">
-                <a:solidFill>
-                  <a:srgbClr val="0563C1"/>
-                </a:solidFill>
-                <a:latin typeface="Calibri"/>
-                <a:hlinkClick r:id="rId4"/>
-              </a:rPr>
-              <a:t>github.com</a:t>
+              <a:t>•  GitHub: create a free account at github.com</a:t>
             </a:r>
           </a:p>
           <a:p>
@@ -8857,7 +7346,7 @@
         <p:spPr>
           <a:xfrm>
             <a:off x="502920" y="1554480"/>
-            <a:ext cx="11185855" cy="1395254"/>
+            <a:ext cx="11185855" cy="4892040"/>
           </a:xfrm>
           <a:prstGeom prst="rect">
             <a:avLst/>
@@ -8876,7 +7365,7 @@
               </a:spcAft>
             </a:pPr>
             <a:r>
-              <a:rPr sz="1700" b="0" i="0" dirty="0">
+              <a:rPr sz="1700" b="0" i="0">
                 <a:solidFill>
                   <a:srgbClr val="232323"/>
                 </a:solidFill>
@@ -8892,7 +7381,7 @@
               </a:spcAft>
             </a:pPr>
             <a:r>
-              <a:rPr sz="1700" b="0" i="0" dirty="0">
+              <a:rPr sz="1700" b="0" i="0">
                 <a:solidFill>
                   <a:srgbClr val="232323"/>
                 </a:solidFill>
@@ -8908,31 +7397,29 @@
               </a:spcAft>
             </a:pPr>
             <a:r>
-              <a:rPr sz="1700" b="0" i="0" dirty="0">
+              <a:rPr sz="1700" b="0" i="0">
                 <a:solidFill>
                   <a:srgbClr val="232323"/>
                 </a:solidFill>
                 <a:latin typeface="Calibri"/>
               </a:rPr>
-              <a:t>•  Where the assumptions live: docs/financing_pathway.md, docs/energy_efficiency_pathway.md, </a:t>
-            </a:r>
-            <a:r>
-              <a:rPr sz="1700" b="0" i="0" dirty="0" err="1">
+              <a:t>•  Where the assumptions live: docs/financing_pathway.md, docs/energy_efficiency_pathway.md, ExcelFiles/</a:t>
+            </a:r>
+          </a:p>
+          <a:p>
+            <a:pPr marL="0" indent="0">
+              <a:spcAft>
+                <a:spcPts val="1000"/>
+              </a:spcAft>
+            </a:pPr>
+            <a:r>
+              <a:rPr sz="1700" b="1" i="0">
                 <a:solidFill>
                   <a:srgbClr val="232323"/>
                 </a:solidFill>
                 <a:latin typeface="Calibri"/>
               </a:rPr>
-              <a:t>ExcelFiles</a:t>
-            </a:r>
-            <a:r>
-              <a:rPr sz="1700" b="0" i="0" dirty="0">
-                <a:solidFill>
-                  <a:srgbClr val="232323"/>
-                </a:solidFill>
-                <a:latin typeface="Calibri"/>
-              </a:rPr>
-              <a:t>/</a:t>
+              <a:t>•  Full codebase navigation and Git/GitHub Desktop are taught tomorrow morning, right before you need them hands-on — not repeated here</a:t>
             </a:r>
           </a:p>
         </p:txBody>
@@ -9274,7 +7761,7 @@
                 </a:solidFill>
                 <a:latin typeface="Calibri"/>
               </a:rPr>
-              <a:t>•  Affordability of public investment — shifting capital toward the cheaper government-sourced channel cuts r_G from 7.37% (market-led) to 5.07% (public-led), saving an estimated USD 1–3bn/year in financing costs on Vietnam's ~USD 136bn PDP8 energy investment need</a:t>
+              <a:t>•  Affordability of public investment — lower borrowing rates reduce the debt-service burden of transition investment</a:t>
             </a:r>
           </a:p>
           <a:p>
@@ -9290,7 +7777,7 @@
                 </a:solidFill>
                 <a:latin typeface="Calibri"/>
               </a:rPr>
-              <a:t>•  Investment crowd-in — the model shocks capital-source rates directly: r_G and r_FDI in the renewable sector, each paired with a target capital share (K_G share, K_FDI share) — not fiscal transfers. A cheaper, larger-share public/FDI channel lowers the effective cost of new renewable capacity and crowds in more of it</a:t>
+              <a:t>•  Investment crowd-in — recycling emission-tax revenue into renewable capital can fund additional capacity without new borrowing</a:t>
             </a:r>
           </a:p>
           <a:p>
@@ -9306,7 +7793,7 @@
                 </a:solidFill>
                 <a:latin typeface="Calibri"/>
               </a:rPr>
-              <a:t>•  Financing value scales with ambition — the same r_G / r_FDI cut delivers a larger GDP dividend under Net-Zero than under PDP8, because NZ requires faster, more front-loaded capital formation</a:t>
+              <a:t>•  Policy credibility — transparent, pre-announced financing rules improve implementation certainty for investors</a:t>
             </a:r>
           </a:p>
         </p:txBody>
@@ -9454,7 +7941,7 @@
               </a:spcAft>
             </a:pPr>
             <a:r>
-              <a:rPr sz="1100" b="1" i="0">
+              <a:rPr sz="1100" b="1" i="0" dirty="0">
                 <a:solidFill>
                   <a:srgbClr val="FFD2D2"/>
                 </a:solidFill>
@@ -9465,13 +7952,13 @@
           </a:p>
           <a:p>
             <a:r>
-              <a:rPr sz="2400" b="1" i="0">
+              <a:rPr sz="2400" b="1" i="0" dirty="0">
                 <a:solidFill>
                   <a:srgbClr val="FFFFFF"/>
                 </a:solidFill>
                 <a:latin typeface="Calibri"/>
               </a:rPr>
-              <a:t>The Six-Scenario Finance Matrix</a:t>
+              <a:t>The Finance Matrix: Three Structures x Two Pathways</a:t>
             </a:r>
           </a:p>
         </p:txBody>
@@ -9620,11 +8107,17 @@
           <p:cNvGraphicFramePr>
             <a:graphicFrameLocks noGrp="1"/>
           </p:cNvGraphicFramePr>
-          <p:nvPr/>
+          <p:nvPr>
+            <p:extLst>
+              <p:ext uri="{D42A27DB-BD31-4B8C-83A1-F6EECF244321}">
+                <p14:modId xmlns:p14="http://schemas.microsoft.com/office/powerpoint/2010/main" val="3057686353"/>
+              </p:ext>
+            </p:extLst>
+          </p:nvPr>
         </p:nvGraphicFramePr>
         <p:xfrm>
           <a:off x="502920" y="1554480"/>
-          <a:ext cx="11185855" cy="4389120"/>
+          <a:ext cx="11185852" cy="4389120"/>
         </p:xfrm>
         <a:graphic>
           <a:graphicData uri="http://schemas.openxmlformats.org/drawingml/2006/table">
@@ -9633,45 +8126,38 @@
                 <a:tableStyleId>{5C22544A-7EE6-4342-B048-85BDC9FD1C3A}</a:tableStyleId>
               </a:tblPr>
               <a:tblGrid>
-                <a:gridCol w="1143000">
+                <a:gridCol w="2260970">
                   <a:extLst>
                     <a:ext uri="{9D8B030D-6E8A-4147-A177-3AD203B41FA5}">
                       <a16:colId xmlns:a16="http://schemas.microsoft.com/office/drawing/2014/main" val="20000"/>
                     </a:ext>
                   </a:extLst>
                 </a:gridCol>
-                <a:gridCol w="2011680">
-                  <a:extLst>
-                    <a:ext uri="{9D8B030D-6E8A-4147-A177-3AD203B41FA5}">
-                      <a16:colId xmlns:a16="http://schemas.microsoft.com/office/drawing/2014/main" val="2027371714"/>
-                    </a:ext>
-                  </a:extLst>
-                </a:gridCol>
-                <a:gridCol w="1417320">
+                <a:gridCol w="1784976">
                   <a:extLst>
                     <a:ext uri="{9D8B030D-6E8A-4147-A177-3AD203B41FA5}">
                       <a16:colId xmlns:a16="http://schemas.microsoft.com/office/drawing/2014/main" val="20001"/>
                     </a:ext>
                   </a:extLst>
                 </a:gridCol>
-                <a:gridCol w="2011680">
+                <a:gridCol w="2498967">
                   <a:extLst>
                     <a:ext uri="{9D8B030D-6E8A-4147-A177-3AD203B41FA5}">
                       <a16:colId xmlns:a16="http://schemas.microsoft.com/office/drawing/2014/main" val="20002"/>
                     </a:ext>
                   </a:extLst>
                 </a:gridCol>
-                <a:gridCol w="2011680">
+                <a:gridCol w="2498967">
                   <a:extLst>
                     <a:ext uri="{9D8B030D-6E8A-4147-A177-3AD203B41FA5}">
                       <a16:colId xmlns:a16="http://schemas.microsoft.com/office/drawing/2014/main" val="20003"/>
                     </a:ext>
                   </a:extLst>
                 </a:gridCol>
-                <a:gridCol w="2590495">
+                <a:gridCol w="2141972">
                   <a:extLst>
                     <a:ext uri="{9D8B030D-6E8A-4147-A177-3AD203B41FA5}">
-                      <a16:colId xmlns:a16="http://schemas.microsoft.com/office/drawing/2014/main" val="1573726024"/>
+                      <a16:colId xmlns:a16="http://schemas.microsoft.com/office/drawing/2014/main" val="20004"/>
                     </a:ext>
                   </a:extLst>
                 </a:gridCol>
@@ -9683,29 +8169,7 @@
                     <a:lstStyle/>
                     <a:p>
                       <a:r>
-                        <a:rPr sz="1300" b="1" i="0">
-                          <a:solidFill>
-                            <a:srgbClr val="FFFFFF"/>
-                          </a:solidFill>
-                          <a:latin typeface="Calibri"/>
-                        </a:rPr>
-                        <a:t>Group</a:t>
-                      </a:r>
-                    </a:p>
-                  </a:txBody>
-                  <a:tcPr marT="50800" marB="50800" anchor="ctr">
-                    <a:solidFill>
-                      <a:srgbClr val="CC071E"/>
-                    </a:solidFill>
-                  </a:tcPr>
-                </a:tc>
-                <a:tc>
-                  <a:txBody>
-                    <a:bodyPr/>
-                    <a:lstStyle/>
-                    <a:p>
-                      <a:r>
-                        <a:rPr sz="1300" b="1" i="0">
+                        <a:rPr sz="1300" b="1" i="0" dirty="0">
                           <a:solidFill>
                             <a:srgbClr val="FFFFFF"/>
                           </a:solidFill>
@@ -9733,29 +8197,7 @@
                           </a:solidFill>
                           <a:latin typeface="Calibri"/>
                         </a:rPr>
-                        <a:t>Emissions pathway</a:t>
-                      </a:r>
-                    </a:p>
-                  </a:txBody>
-                  <a:tcPr marT="50800" marB="50800" anchor="ctr">
-                    <a:solidFill>
-                      <a:srgbClr val="CC071E"/>
-                    </a:solidFill>
-                  </a:tcPr>
-                </a:tc>
-                <a:tc>
-                  <a:txBody>
-                    <a:bodyPr/>
-                    <a:lstStyle/>
-                    <a:p>
-                      <a:r>
-                        <a:rPr sz="1300" b="1" i="0" dirty="0">
-                          <a:solidFill>
-                            <a:srgbClr val="FFFFFF"/>
-                          </a:solidFill>
-                          <a:latin typeface="Calibri"/>
-                        </a:rPr>
-                        <a:t>Financing structure</a:t>
+                        <a:t>Pathway</a:t>
                       </a:r>
                     </a:p>
                   </a:txBody>
@@ -9777,7 +8219,7 @@
                           </a:solidFill>
                           <a:latin typeface="Calibri"/>
                         </a:rPr>
-                        <a:t>r_G / r_FDI (%)</a:t>
+                        <a:t>Structure</a:t>
                       </a:r>
                     </a:p>
                   </a:txBody>
@@ -9799,7 +8241,29 @@
                           </a:solidFill>
                           <a:latin typeface="Calibri"/>
                         </a:rPr>
-                        <a:t>K_G / K_FDI share (%)</a:t>
+                        <a:t>r_G / r_FDI</a:t>
+                      </a:r>
+                    </a:p>
+                  </a:txBody>
+                  <a:tcPr marT="50800" marB="50800" anchor="ctr">
+                    <a:solidFill>
+                      <a:srgbClr val="CC071E"/>
+                    </a:solidFill>
+                  </a:tcPr>
+                </a:tc>
+                <a:tc>
+                  <a:txBody>
+                    <a:bodyPr/>
+                    <a:lstStyle/>
+                    <a:p>
+                      <a:r>
+                        <a:rPr sz="1300" b="1" i="0">
+                          <a:solidFill>
+                            <a:srgbClr val="FFFFFF"/>
+                          </a:solidFill>
+                          <a:latin typeface="Calibri"/>
+                        </a:rPr>
+                        <a:t>K_G / K_FDI</a:t>
                       </a:r>
                     </a:p>
                   </a:txBody>
@@ -9822,29 +8286,7 @@
                     <a:lstStyle/>
                     <a:p>
                       <a:r>
-                        <a:rPr sz="1300" b="1" i="0">
-                          <a:solidFill>
-                            <a:srgbClr val="232323"/>
-                          </a:solidFill>
-                          <a:latin typeface="Calibri"/>
-                        </a:rPr>
-                        <a:t>Group 1</a:t>
-                      </a:r>
-                    </a:p>
-                  </a:txBody>
-                  <a:tcPr marT="38100" marB="38100" anchor="ctr">
-                    <a:solidFill>
-                      <a:srgbClr val="FFFFFF"/>
-                    </a:solidFill>
-                  </a:tcPr>
-                </a:tc>
-                <a:tc>
-                  <a:txBody>
-                    <a:bodyPr/>
-                    <a:lstStyle/>
-                    <a:p>
-                      <a:r>
-                        <a:rPr sz="1300" b="1" i="0">
+                        <a:rPr sz="1300" b="1" i="0" dirty="0">
                           <a:solidFill>
                             <a:srgbClr val="232323"/>
                           </a:solidFill>
@@ -9894,7 +8336,7 @@
                           </a:solidFill>
                           <a:latin typeface="Calibri"/>
                         </a:rPr>
-                        <a:t>Balanced (ODA/MDB + green bonds)</a:t>
+                        <a:t>A Balanced</a:t>
                       </a:r>
                     </a:p>
                   </a:txBody>
@@ -9910,13 +8352,13 @@
                     <a:lstStyle/>
                     <a:p>
                       <a:r>
-                        <a:rPr sz="1300" b="0" i="0" dirty="0">
+                        <a:rPr sz="1300" b="0" i="0">
                           <a:solidFill>
                             <a:srgbClr val="232323"/>
                           </a:solidFill>
                           <a:latin typeface="Calibri"/>
                         </a:rPr>
-                        <a:t>6.43 / 6.36</a:t>
+                        <a:t>6.43% / 6.36%</a:t>
                       </a:r>
                     </a:p>
                   </a:txBody>
@@ -9932,13 +8374,13 @@
                     <a:lstStyle/>
                     <a:p>
                       <a:r>
-                        <a:rPr sz="1300" b="0" i="0" dirty="0">
+                        <a:rPr sz="1300" b="0" i="0">
                           <a:solidFill>
                             <a:srgbClr val="232323"/>
                           </a:solidFill>
                           <a:latin typeface="Calibri"/>
                         </a:rPr>
-                        <a:t>19.0 / 14.0</a:t>
+                        <a:t>19.0% / 14.0%</a:t>
                       </a:r>
                     </a:p>
                   </a:txBody>
@@ -9961,29 +8403,7 @@
                     <a:lstStyle/>
                     <a:p>
                       <a:r>
-                        <a:rPr sz="1300" b="1" i="0">
-                          <a:solidFill>
-                            <a:srgbClr val="232323"/>
-                          </a:solidFill>
-                          <a:latin typeface="Calibri"/>
-                        </a:rPr>
-                        <a:t>Group 1</a:t>
-                      </a:r>
-                    </a:p>
-                  </a:txBody>
-                  <a:tcPr marT="38100" marB="38100" anchor="ctr">
-                    <a:solidFill>
-                      <a:srgbClr val="F5F5F5"/>
-                    </a:solidFill>
-                  </a:tcPr>
-                </a:tc>
-                <a:tc>
-                  <a:txBody>
-                    <a:bodyPr/>
-                    <a:lstStyle/>
-                    <a:p>
-                      <a:r>
-                        <a:rPr sz="1300" b="1" i="0">
+                        <a:rPr sz="1300" b="1" i="0" dirty="0">
                           <a:solidFill>
                             <a:srgbClr val="232323"/>
                           </a:solidFill>
@@ -10005,13 +8425,13 @@
                     <a:lstStyle/>
                     <a:p>
                       <a:r>
-                        <a:rPr sz="1300" b="0" i="0">
+                        <a:rPr sz="1300" b="0" i="0" dirty="0">
                           <a:solidFill>
                             <a:srgbClr val="232323"/>
                           </a:solidFill>
                           <a:latin typeface="Calibri"/>
                         </a:rPr>
-                        <a:t>Net-Zero</a:t>
+                        <a:t>Net Zero</a:t>
                       </a:r>
                     </a:p>
                   </a:txBody>
@@ -10033,7 +8453,7 @@
                           </a:solidFill>
                           <a:latin typeface="Calibri"/>
                         </a:rPr>
-                        <a:t>Balanced (ODA/MDB + green bonds)</a:t>
+                        <a:t>A Balanced</a:t>
                       </a:r>
                     </a:p>
                   </a:txBody>
@@ -10055,7 +8475,7 @@
                           </a:solidFill>
                           <a:latin typeface="Calibri"/>
                         </a:rPr>
-                        <a:t>6.43 / 6.36</a:t>
+                        <a:t>6.43% / 6.36%</a:t>
                       </a:r>
                     </a:p>
                   </a:txBody>
@@ -10077,7 +8497,7 @@
                           </a:solidFill>
                           <a:latin typeface="Calibri"/>
                         </a:rPr>
-                        <a:t>19.0 / 14.0</a:t>
+                        <a:t>19.0% / 14.0%</a:t>
                       </a:r>
                     </a:p>
                   </a:txBody>
@@ -10100,29 +8520,7 @@
                     <a:lstStyle/>
                     <a:p>
                       <a:r>
-                        <a:rPr sz="1300" b="1" i="0">
-                          <a:solidFill>
-                            <a:srgbClr val="232323"/>
-                          </a:solidFill>
-                          <a:latin typeface="Calibri"/>
-                        </a:rPr>
-                        <a:t>Group 2</a:t>
-                      </a:r>
-                    </a:p>
-                  </a:txBody>
-                  <a:tcPr marT="38100" marB="38100" anchor="ctr">
-                    <a:solidFill>
-                      <a:srgbClr val="FFFFFF"/>
-                    </a:solidFill>
-                  </a:tcPr>
-                </a:tc>
-                <a:tc>
-                  <a:txBody>
-                    <a:bodyPr/>
-                    <a:lstStyle/>
-                    <a:p>
-                      <a:r>
-                        <a:rPr sz="1300" b="1" i="0">
+                        <a:rPr sz="1300" b="1" i="0" dirty="0">
                           <a:solidFill>
                             <a:srgbClr val="232323"/>
                           </a:solidFill>
@@ -10144,7 +8542,7 @@
                     <a:lstStyle/>
                     <a:p>
                       <a:r>
-                        <a:rPr sz="1300" b="0" i="0">
+                        <a:rPr sz="1300" b="0" i="0" dirty="0">
                           <a:solidFill>
                             <a:srgbClr val="232323"/>
                           </a:solidFill>
@@ -10166,13 +8564,13 @@
                     <a:lstStyle/>
                     <a:p>
                       <a:r>
-                        <a:rPr sz="1300" b="0" i="0">
+                        <a:rPr sz="1300" b="0" i="0" dirty="0">
                           <a:solidFill>
                             <a:srgbClr val="232323"/>
                           </a:solidFill>
                           <a:latin typeface="Calibri"/>
                         </a:rPr>
-                        <a:t>Market-led (commercial/private)</a:t>
+                        <a:t>B Market-led</a:t>
                       </a:r>
                     </a:p>
                   </a:txBody>
@@ -10194,7 +8592,7 @@
                           </a:solidFill>
                           <a:latin typeface="Calibri"/>
                         </a:rPr>
-                        <a:t>7.37 / 6.90</a:t>
+                        <a:t>7.37% / 6.90%</a:t>
                       </a:r>
                     </a:p>
                   </a:txBody>
@@ -10216,7 +8614,7 @@
                           </a:solidFill>
                           <a:latin typeface="Calibri"/>
                         </a:rPr>
-                        <a:t>9.6 / 12.4</a:t>
+                        <a:t>9.6% / 12.4%</a:t>
                       </a:r>
                     </a:p>
                   </a:txBody>
@@ -10239,29 +8637,7 @@
                     <a:lstStyle/>
                     <a:p>
                       <a:r>
-                        <a:rPr sz="1300" b="1" i="0">
-                          <a:solidFill>
-                            <a:srgbClr val="232323"/>
-                          </a:solidFill>
-                          <a:latin typeface="Calibri"/>
-                        </a:rPr>
-                        <a:t>Group 2</a:t>
-                      </a:r>
-                    </a:p>
-                  </a:txBody>
-                  <a:tcPr marT="38100" marB="38100" anchor="ctr">
-                    <a:solidFill>
-                      <a:srgbClr val="F5F5F5"/>
-                    </a:solidFill>
-                  </a:tcPr>
-                </a:tc>
-                <a:tc>
-                  <a:txBody>
-                    <a:bodyPr/>
-                    <a:lstStyle/>
-                    <a:p>
-                      <a:r>
-                        <a:rPr sz="1300" b="1" i="0">
+                        <a:rPr sz="1300" b="1" i="0" dirty="0">
                           <a:solidFill>
                             <a:srgbClr val="232323"/>
                           </a:solidFill>
@@ -10283,13 +8659,35 @@
                     <a:lstStyle/>
                     <a:p>
                       <a:r>
-                        <a:rPr sz="1300" b="0" i="0">
+                        <a:rPr sz="1300" b="0" i="0" dirty="0">
                           <a:solidFill>
                             <a:srgbClr val="232323"/>
                           </a:solidFill>
                           <a:latin typeface="Calibri"/>
                         </a:rPr>
-                        <a:t>Net-Zero</a:t>
+                        <a:t>Net Zero</a:t>
+                      </a:r>
+                    </a:p>
+                  </a:txBody>
+                  <a:tcPr marT="38100" marB="38100" anchor="ctr">
+                    <a:solidFill>
+                      <a:srgbClr val="F5F5F5"/>
+                    </a:solidFill>
+                  </a:tcPr>
+                </a:tc>
+                <a:tc>
+                  <a:txBody>
+                    <a:bodyPr/>
+                    <a:lstStyle/>
+                    <a:p>
+                      <a:r>
+                        <a:rPr sz="1300" b="0" i="0" dirty="0">
+                          <a:solidFill>
+                            <a:srgbClr val="232323"/>
+                          </a:solidFill>
+                          <a:latin typeface="Calibri"/>
+                        </a:rPr>
+                        <a:t>B Market-led</a:t>
                       </a:r>
                     </a:p>
                   </a:txBody>
@@ -10311,7 +8709,7 @@
                           </a:solidFill>
                           <a:latin typeface="Calibri"/>
                         </a:rPr>
-                        <a:t>Market-led (commercial/private)</a:t>
+                        <a:t>7.37% / 6.90%</a:t>
                       </a:r>
                     </a:p>
                   </a:txBody>
@@ -10327,35 +8725,13 @@
                     <a:lstStyle/>
                     <a:p>
                       <a:r>
-                        <a:rPr sz="1300" b="0" i="0" dirty="0">
+                        <a:rPr sz="1300" b="0" i="0">
                           <a:solidFill>
                             <a:srgbClr val="232323"/>
                           </a:solidFill>
                           <a:latin typeface="Calibri"/>
                         </a:rPr>
-                        <a:t>7.37 / 6.90</a:t>
-                      </a:r>
-                    </a:p>
-                  </a:txBody>
-                  <a:tcPr marT="38100" marB="38100" anchor="ctr">
-                    <a:solidFill>
-                      <a:srgbClr val="F5F5F5"/>
-                    </a:solidFill>
-                  </a:tcPr>
-                </a:tc>
-                <a:tc>
-                  <a:txBody>
-                    <a:bodyPr/>
-                    <a:lstStyle/>
-                    <a:p>
-                      <a:r>
-                        <a:rPr sz="1300" b="0" i="0" dirty="0">
-                          <a:solidFill>
-                            <a:srgbClr val="232323"/>
-                          </a:solidFill>
-                          <a:latin typeface="Calibri"/>
-                        </a:rPr>
-                        <a:t>9.6 / 12.4</a:t>
+                        <a:t>9.6% / 12.4%</a:t>
                       </a:r>
                     </a:p>
                   </a:txBody>
@@ -10378,29 +8754,7 @@
                     <a:lstStyle/>
                     <a:p>
                       <a:r>
-                        <a:rPr sz="1300" b="1" i="0">
-                          <a:solidFill>
-                            <a:srgbClr val="232323"/>
-                          </a:solidFill>
-                          <a:latin typeface="Calibri"/>
-                        </a:rPr>
-                        <a:t>Group 3</a:t>
-                      </a:r>
-                    </a:p>
-                  </a:txBody>
-                  <a:tcPr marT="38100" marB="38100" anchor="ctr">
-                    <a:solidFill>
-                      <a:srgbClr val="FFFFFF"/>
-                    </a:solidFill>
-                  </a:tcPr>
-                </a:tc>
-                <a:tc>
-                  <a:txBody>
-                    <a:bodyPr/>
-                    <a:lstStyle/>
-                    <a:p>
-                      <a:r>
-                        <a:rPr sz="1300" b="1" i="0">
+                        <a:rPr sz="1300" b="1" i="0" dirty="0">
                           <a:solidFill>
                             <a:srgbClr val="232323"/>
                           </a:solidFill>
@@ -10422,7 +8776,7 @@
                     <a:lstStyle/>
                     <a:p>
                       <a:r>
-                        <a:rPr sz="1300" b="0" i="0">
+                        <a:rPr sz="1300" b="0" i="0" dirty="0">
                           <a:solidFill>
                             <a:srgbClr val="232323"/>
                           </a:solidFill>
@@ -10444,13 +8798,13 @@
                     <a:lstStyle/>
                     <a:p>
                       <a:r>
-                        <a:rPr sz="1300" b="0" i="0">
+                        <a:rPr sz="1300" b="0" i="0" dirty="0">
                           <a:solidFill>
                             <a:srgbClr val="232323"/>
                           </a:solidFill>
                           <a:latin typeface="Calibri"/>
                         </a:rPr>
-                        <a:t>Public-led (ODA/concessional)</a:t>
+                        <a:t>C Public-led</a:t>
                       </a:r>
                     </a:p>
                   </a:txBody>
@@ -10472,7 +8826,7 @@
                           </a:solidFill>
                           <a:latin typeface="Calibri"/>
                         </a:rPr>
-                        <a:t>5.07 / 6.00</a:t>
+                        <a:t>5.07% / 6.00%</a:t>
                       </a:r>
                     </a:p>
                   </a:txBody>
@@ -10494,7 +8848,7 @@
                           </a:solidFill>
                           <a:latin typeface="Calibri"/>
                         </a:rPr>
-                        <a:t>36.5 / 19.0</a:t>
+                        <a:t>36.5% / 19.0%</a:t>
                       </a:r>
                     </a:p>
                   </a:txBody>
@@ -10517,29 +8871,7 @@
                     <a:lstStyle/>
                     <a:p>
                       <a:r>
-                        <a:rPr sz="1300" b="1" i="0">
-                          <a:solidFill>
-                            <a:srgbClr val="232323"/>
-                          </a:solidFill>
-                          <a:latin typeface="Calibri"/>
-                        </a:rPr>
-                        <a:t>Group 3</a:t>
-                      </a:r>
-                    </a:p>
-                  </a:txBody>
-                  <a:tcPr marT="38100" marB="38100" anchor="ctr">
-                    <a:solidFill>
-                      <a:srgbClr val="F5F5F5"/>
-                    </a:solidFill>
-                  </a:tcPr>
-                </a:tc>
-                <a:tc>
-                  <a:txBody>
-                    <a:bodyPr/>
-                    <a:lstStyle/>
-                    <a:p>
-                      <a:r>
-                        <a:rPr sz="1300" b="1" i="0">
+                        <a:rPr sz="1300" b="1" i="0" dirty="0">
                           <a:solidFill>
                             <a:srgbClr val="232323"/>
                           </a:solidFill>
@@ -10567,29 +8899,7 @@
                           </a:solidFill>
                           <a:latin typeface="Calibri"/>
                         </a:rPr>
-                        <a:t>Net-Zero</a:t>
-                      </a:r>
-                    </a:p>
-                  </a:txBody>
-                  <a:tcPr marT="38100" marB="38100" anchor="ctr">
-                    <a:solidFill>
-                      <a:srgbClr val="F5F5F5"/>
-                    </a:solidFill>
-                  </a:tcPr>
-                </a:tc>
-                <a:tc>
-                  <a:txBody>
-                    <a:bodyPr/>
-                    <a:lstStyle/>
-                    <a:p>
-                      <a:r>
-                        <a:rPr sz="1300" b="0" i="0">
-                          <a:solidFill>
-                            <a:srgbClr val="232323"/>
-                          </a:solidFill>
-                          <a:latin typeface="Calibri"/>
-                        </a:rPr>
-                        <a:t>Public-led (ODA/concessional)</a:t>
+                        <a:t>Net Zero</a:t>
                       </a:r>
                     </a:p>
                   </a:txBody>
@@ -10611,7 +8921,7 @@
                           </a:solidFill>
                           <a:latin typeface="Calibri"/>
                         </a:rPr>
-                        <a:t>5.07 / 6.00</a:t>
+                        <a:t>C Public-led</a:t>
                       </a:r>
                     </a:p>
                   </a:txBody>
@@ -10633,7 +8943,29 @@
                           </a:solidFill>
                           <a:latin typeface="Calibri"/>
                         </a:rPr>
-                        <a:t>36.5 / 19.0</a:t>
+                        <a:t>5.07% / 6.00%</a:t>
+                      </a:r>
+                    </a:p>
+                  </a:txBody>
+                  <a:tcPr marT="38100" marB="38100" anchor="ctr">
+                    <a:solidFill>
+                      <a:srgbClr val="F5F5F5"/>
+                    </a:solidFill>
+                  </a:tcPr>
+                </a:tc>
+                <a:tc>
+                  <a:txBody>
+                    <a:bodyPr/>
+                    <a:lstStyle/>
+                    <a:p>
+                      <a:r>
+                        <a:rPr sz="1300" b="0" i="0" dirty="0">
+                          <a:solidFill>
+                            <a:srgbClr val="232323"/>
+                          </a:solidFill>
+                          <a:latin typeface="Calibri"/>
+                        </a:rPr>
+                        <a:t>36.5% / 19.0%</a:t>
                       </a:r>
                     </a:p>
                   </a:txBody>
@@ -10661,8 +8993,8 @@
         </p:nvSpPr>
         <p:spPr>
           <a:xfrm>
-            <a:off x="502920" y="5870448"/>
-            <a:ext cx="11185855" cy="640080"/>
+            <a:off x="502920" y="5943600"/>
+            <a:ext cx="11185855" cy="566928"/>
           </a:xfrm>
           <a:prstGeom prst="roundRect">
             <a:avLst/>
@@ -10703,7 +9035,7 @@
                 </a:solidFill>
                 <a:latin typeface="Calibri"/>
               </a:rPr>
-              <a:t>r_G/r_FDI = sector-3 financing rate by capital source; K_G/K_FDI share = target share of sector-3 capital financed via each. Compare only within the SAME emissions pathway.</a:t>
+              <a:t>Compare financing structures within the SAME emissions pathway only; the pathway itself is a separate source of difference.</a:t>
             </a:r>
           </a:p>
         </p:txBody>
@@ -11020,7 +9352,7 @@
         <p:spPr>
           <a:xfrm>
             <a:off x="502920" y="1554480"/>
-            <a:ext cx="11185855" cy="2954655"/>
+            <a:ext cx="11185855" cy="4892040"/>
           </a:xfrm>
           <a:prstGeom prst="rect">
             <a:avLst/>
@@ -11033,154 +9365,61 @@
           </a:bodyPr>
           <a:lstStyle/>
           <a:p>
-            <a:pPr marL="0" indent="0" algn="just">
+            <a:pPr marL="0" indent="0">
               <a:spcAft>
                 <a:spcPts val="1000"/>
               </a:spcAft>
             </a:pPr>
             <a:r>
-              <a:rPr sz="1700" b="0" i="0" dirty="0">
+              <a:rPr sz="1700" b="0" i="0">
                 <a:solidFill>
                   <a:srgbClr val="232323"/>
                 </a:solidFill>
                 <a:latin typeface="Calibri"/>
               </a:rPr>
-              <a:t>•  Your group is assigned one of the three financing structures — Group 1 = A (Balanced), Group 2 = B (Market-led), Group 3 = C (Public-led) — cover both the PDP8 and Net-Zero pathway variants for your structure</a:t>
-            </a:r>
-            <a:endParaRPr lang="en-US" sz="1700" b="0" i="0" dirty="0">
-              <a:solidFill>
-                <a:srgbClr val="232323"/>
-              </a:solidFill>
-              <a:latin typeface="Calibri"/>
-            </a:endParaRPr>
-          </a:p>
-          <a:p>
-            <a:pPr marL="0" indent="0" algn="just">
+              <a:t>•  Your group is assigned one financing structure (A, B, or C) and documents both pathway variants</a:t>
+            </a:r>
+          </a:p>
+          <a:p>
+            <a:pPr marL="0" indent="0">
               <a:spcAft>
                 <a:spcPts val="1000"/>
               </a:spcAft>
             </a:pPr>
-            <a:endParaRPr sz="1700" b="0" i="0" dirty="0">
-              <a:solidFill>
-                <a:srgbClr val="232323"/>
-              </a:solidFill>
-              <a:latin typeface="Calibri"/>
-            </a:endParaRPr>
-          </a:p>
-          <a:p>
-            <a:pPr marL="0" indent="0" algn="just">
+            <a:r>
+              <a:rPr sz="1700" b="0" i="0">
+                <a:solidFill>
+                  <a:srgbClr val="232323"/>
+                </a:solidFill>
+                <a:latin typeface="Calibri"/>
+              </a:rPr>
+              <a:t>•  Document in full: label, mechanism, exact file edits, exact variables changed, time path, start/end year, transition profile, expected effects, key output indicators, caveats, owner, date</a:t>
+            </a:r>
+          </a:p>
+          <a:p>
+            <a:pPr marL="0" indent="0">
               <a:spcAft>
                 <a:spcPts val="1000"/>
               </a:spcAft>
             </a:pPr>
             <a:r>
-              <a:rPr sz="1700" b="0" i="0" dirty="0">
+              <a:rPr sz="1700" b="0" i="0">
                 <a:solidFill>
                   <a:srgbClr val="232323"/>
                 </a:solidFill>
                 <a:latin typeface="Calibri"/>
               </a:rPr>
-              <a:t>•  Document in full: label, mechanism, exact file edits, exact variables changed, time path, start/end year, transition profile</a:t>
-            </a:r>
-            <a:r>
-              <a:rPr sz="1700" b="0" i="0">
-                <a:solidFill>
-                  <a:srgbClr val="232323"/>
-                </a:solidFill>
-                <a:latin typeface="Calibri"/>
-              </a:rPr>
-              <a:t>,</a:t>
-            </a:r>
-            <a:r>
-              <a:rPr lang="en-US" sz="1700" b="0" i="0">
-                <a:solidFill>
-                  <a:srgbClr val="232323"/>
-                </a:solidFill>
-                <a:latin typeface="Calibri"/>
-              </a:rPr>
-              <a:t> </a:t>
-            </a:r>
-            <a:r>
-              <a:rPr sz="1700" b="0" i="0">
-                <a:solidFill>
-                  <a:srgbClr val="232323"/>
-                </a:solidFill>
-                <a:latin typeface="Calibri"/>
-              </a:rPr>
-              <a:t>expected </a:t>
-            </a:r>
-            <a:r>
-              <a:rPr sz="1700" b="0" i="0" dirty="0">
-                <a:solidFill>
-                  <a:srgbClr val="232323"/>
-                </a:solidFill>
-                <a:latin typeface="Calibri"/>
-              </a:rPr>
-              <a:t>effects, key output indicators, caveats, owner, date</a:t>
-            </a:r>
-            <a:endParaRPr lang="en-US" sz="1700" b="0" i="0" dirty="0">
-              <a:solidFill>
-                <a:srgbClr val="232323"/>
-              </a:solidFill>
-              <a:latin typeface="Calibri"/>
-            </a:endParaRPr>
-          </a:p>
-          <a:p>
-            <a:pPr marL="0" indent="0" algn="just">
+              <a:t>•  Also state: which same-pathway structure to compare against, and which of r_G, r_FDI, K_G share, K_FDI share differ</a:t>
+            </a:r>
+          </a:p>
+          <a:p>
+            <a:pPr marL="0" indent="0">
               <a:spcAft>
                 <a:spcPts val="1000"/>
               </a:spcAft>
             </a:pPr>
-            <a:endParaRPr sz="1700" b="0" i="0" dirty="0">
-              <a:solidFill>
-                <a:srgbClr val="232323"/>
-              </a:solidFill>
-              <a:latin typeface="Calibri"/>
-            </a:endParaRPr>
-          </a:p>
-          <a:p>
-            <a:pPr marL="0" indent="0" algn="just">
-              <a:spcAft>
-                <a:spcPts val="1000"/>
-              </a:spcAft>
-            </a:pPr>
-            <a:r>
-              <a:rPr sz="1700" b="0" i="0" dirty="0">
-                <a:solidFill>
-                  <a:srgbClr val="232323"/>
-                </a:solidFill>
-                <a:latin typeface="Calibri"/>
-              </a:rPr>
-              <a:t>•  Also state: which of the other two financing structures (A/B/C, same emissions pathway) you compare against, and what differs — r_G, r_FDI, K_G share, K_FDI share</a:t>
-            </a:r>
-            <a:endParaRPr lang="en-US" sz="1700" b="0" i="0" dirty="0">
-              <a:solidFill>
-                <a:srgbClr val="232323"/>
-              </a:solidFill>
-              <a:latin typeface="Calibri"/>
-            </a:endParaRPr>
-          </a:p>
-          <a:p>
-            <a:pPr marL="0" indent="0" algn="just">
-              <a:spcAft>
-                <a:spcPts val="1000"/>
-              </a:spcAft>
-            </a:pPr>
-            <a:endParaRPr sz="1700" b="0" i="0" dirty="0">
-              <a:solidFill>
-                <a:srgbClr val="232323"/>
-              </a:solidFill>
-              <a:latin typeface="Calibri"/>
-            </a:endParaRPr>
-          </a:p>
-          <a:p>
-            <a:pPr marL="0" indent="0" algn="just">
-              <a:spcAft>
-                <a:spcPts val="1000"/>
-              </a:spcAft>
-            </a:pPr>
-            <a:r>
-              <a:rPr sz="1700" b="1" i="0" dirty="0">
+            <a:r>
+              <a:rPr sz="1700" b="1" i="0">
                 <a:solidFill>
                   <a:srgbClr val="232323"/>
                 </a:solidFill>

</xml_diff>